<commit_message>
Revise the slide for a deputy secretary election.
Drop the photo, birth date, and hometown, and foreground party-join dates plus service as class organization committee member.

Co-authored-by: ISAAC558345 <ISAAC558345@users.noreply.github.com>
</commit_message>
<xml_diff>
--- a/入党自我介绍_一页.pptx
+++ b/入党自我介绍_一页.pptx
@@ -502,7 +502,7 @@
           <a:lstStyle/>
           <a:p>
             <a:r>
-              <a:t>讲解稿（大约两分钟）。带【】的句子，请改成你自己的事实后再讲。不要照着空着的“请填写”直接念。</a:t>
+              <a:t>竞选副书记讲解稿（大约两分钟）。红字“请填写”先改成事实再讲。</a:t>
             </a:r>
           </a:p>
           <a:p/>
@@ -513,64 +513,37 @@
           </a:p>
           <a:p>
             <a:r>
-              <a:t>我申请加入中国共产党，先用两分钟介绍自己。</a:t>
+              <a:t>我竞选党支部副书记，先用两分钟介绍自己。</a:t>
             </a:r>
           </a:p>
           <a:p/>
           <a:p>
             <a:r>
-              <a:t>我叫【姓名】，【性别】，【民族】，【出生年月】出生，籍贯【籍贯】。现在的学历和专业是【学历、学校、专业或工作单位、职务】，政治面貌是【共青团员或群众，按实填写】。</a:t>
+              <a:t>我叫【姓名】，【性别】，【民族】，专业是【专业】，中共党员。我于【入党时间】加入中国共产党，于【转正时间】转正。</a:t>
             </a:r>
           </a:p>
           <a:p/>
           <a:p>
             <a:r>
-              <a:t>家庭主要成员我简要说明：【父亲、母亲，以及有没有其他需要向组织说明的主要社会关系；写明称谓、工作或生活状况、政治面貌】。</a:t>
+              <a:t>我曾担任班级组织委员。任职期间，我协助班级做好推优和入党积极分子的培养联系，了解同学的思想状况，把组织交办的事项按时办完。这段经历让我熟悉发展党员的基本程序，也让我习惯按程序办事、对同学负责。【如需补充，可加上任职起止时间和所在班级】。</a:t>
             </a:r>
           </a:p>
           <a:p/>
           <a:p>
             <a:r>
-              <a:t>个人简历我按时间说：</a:t>
-            </a:r>
-          </a:p>
-          <a:p>
-            <a:r>
-              <a:t>【年月至年月，在哪所学校读书或在哪个单位做什么】。</a:t>
-            </a:r>
-          </a:p>
-          <a:p>
-            <a:r>
-              <a:t>【年月至年月，下一段】。</a:t>
-            </a:r>
-          </a:p>
-          <a:p>
-            <a:r>
-              <a:t>【年月至今，现在这段学习或工作】。</a:t>
+              <a:t>我竞选党支部副书记，是希望在书记带领下，把班级组织委员的经验用到支部。如果当选，我会协助做好党员发展、教育和管理，把组织生活落到实处，及时把同学的情况向支部反映。</a:t>
             </a:r>
           </a:p>
           <a:p/>
           <a:p>
             <a:r>
-              <a:t>我对党的认识是：中国共产党是中国工人阶级的先锋队，同时是中国人民和中华民族的先锋队。党的初心和使命，是为中国人民谋幸福、为中华民族谋复兴。入党对我来说是郑重的政治选择。我愿意在思想上认同，在行动上靠拢，并长期接受组织的教育和考验。</a:t>
+              <a:t>我的优势是熟悉推优和发展党员的程序，交办的事愿意跟到办完。不足是主动沟通还不够，理论学习还要更系统，支部工作也不能只靠班级经验。</a:t>
             </a:r>
           </a:p>
           <a:p/>
           <a:p>
             <a:r>
-              <a:t>我在学习和工作中，习惯把事情做扎实，也明白个人进步离不开集体。我申请入党，是希望按党员标准要求自己：读原著、学原文、悟原理，在专业上练好本领，在集体中主动担当，自觉接受组织考察。</a:t>
-            </a:r>
-          </a:p>
-          <a:p/>
-          <a:p>
-            <a:r>
-              <a:t>对照自己：优点是能沉下心把一件事做完，和身边的人合作时愿意负责到底。不足是有时陷在细节里，主动沟通不够，党的理论学习还不够系统。接下来我会读原著、学原文、悟原理，专业上继续下功夫，在集体中多担当。</a:t>
-            </a:r>
-          </a:p>
-          <a:p/>
-          <a:p>
-            <a:r>
-              <a:t>请组织和同志们批评帮助。我的介绍完了，谢谢大家。</a:t>
+              <a:t>请同志们批评监督。我的介绍完了，谢谢大家。</a:t>
             </a:r>
           </a:p>
           <a:p/>
@@ -3786,7 +3759,7 @@
                 <a:ea typeface="微软雅黑"/>
                 <a:cs typeface="微软雅黑"/>
               </a:rPr>
-              <a:t>入党自我介绍</a:t>
+              <a:t>竞选副书记自我介绍</a:t>
             </a:r>
           </a:p>
         </p:txBody>
@@ -3800,7 +3773,7 @@
         <p:spPr>
           <a:xfrm>
             <a:off x="402336" y="603504"/>
-            <a:ext cx="7498079" cy="256032"/>
+            <a:ext cx="7863840" cy="256032"/>
           </a:xfrm>
           <a:prstGeom prst="rect">
             <a:avLst/>
@@ -3828,7 +3801,7 @@
                 <a:ea typeface="微软雅黑"/>
                 <a:cs typeface="微软雅黑"/>
               </a:rPr>
-              <a:t>发言顺序：基本情况　→　对党的认识　→　入党动机　→　优点、不足、打算</a:t>
+              <a:t>发言顺序：基本情况　→　组织委员经历　→　为何竞选　→　如果当选</a:t>
             </a:r>
           </a:p>
         </p:txBody>
@@ -3841,8 +3814,8 @@
         </p:nvSpPr>
         <p:spPr>
           <a:xfrm>
-            <a:off x="8503920" y="274320"/>
-            <a:ext cx="3291840" cy="438912"/>
+            <a:off x="8366760" y="256032"/>
+            <a:ext cx="3429000" cy="438912"/>
           </a:xfrm>
           <a:prstGeom prst="rect">
             <a:avLst/>
@@ -3870,7 +3843,7 @@
                 <a:ea typeface="微软雅黑"/>
                 <a:cs typeface="微软雅黑"/>
               </a:rPr>
-              <a:t>申请入党</a:t>
+              <a:t>支部选举</a:t>
             </a:r>
           </a:p>
         </p:txBody>
@@ -4097,167 +4070,14 @@
       </p:sp>
       <p:sp>
         <p:nvSpPr>
-          <p:cNvPr id="14" name="Rounded Rectangle 13"/>
-          <p:cNvSpPr/>
-          <p:nvPr/>
-        </p:nvSpPr>
-        <p:spPr>
-          <a:xfrm>
-            <a:off x="475488" y="1627632"/>
-            <a:ext cx="1225296" cy="1591056"/>
-          </a:xfrm>
-          <a:prstGeom prst="roundRect">
-            <a:avLst>
-              <a:gd name="adj" fmla="val 6000"/>
-            </a:avLst>
-          </a:prstGeom>
-          <a:solidFill>
-            <a:srgbClr val="C4A15A"/>
-          </a:solidFill>
-          <a:ln>
-            <a:noFill/>
-          </a:ln>
-        </p:spPr>
-        <p:style>
-          <a:lnRef idx="1">
-            <a:schemeClr val="accent1"/>
-          </a:lnRef>
-          <a:fillRef idx="3">
-            <a:schemeClr val="accent1"/>
-          </a:fillRef>
-          <a:effectRef idx="2">
-            <a:schemeClr val="accent1"/>
-          </a:effectRef>
-          <a:fontRef idx="minor">
-            <a:schemeClr val="lt1"/>
-          </a:fontRef>
-        </p:style>
-        <p:txBody>
-          <a:bodyPr rtlCol="0" anchor="ctr"/>
-          <a:lstStyle/>
-          <a:p>
-            <a:pPr algn="ctr"/>
-          </a:p>
-        </p:txBody>
-      </p:sp>
-      <p:sp>
-        <p:nvSpPr>
-          <p:cNvPr id="15" name="Rounded Rectangle 14"/>
-          <p:cNvSpPr/>
-          <p:nvPr/>
-        </p:nvSpPr>
-        <p:spPr>
-          <a:xfrm>
-            <a:off x="512064" y="1664208"/>
-            <a:ext cx="1152144" cy="1517904"/>
-          </a:xfrm>
-          <a:prstGeom prst="roundRect">
-            <a:avLst>
-              <a:gd name="adj" fmla="val 5000"/>
-            </a:avLst>
-          </a:prstGeom>
-          <a:solidFill>
-            <a:srgbClr val="F3EBE3"/>
-          </a:solidFill>
-          <a:ln>
-            <a:noFill/>
-          </a:ln>
-        </p:spPr>
-        <p:style>
-          <a:lnRef idx="1">
-            <a:schemeClr val="accent1"/>
-          </a:lnRef>
-          <a:fillRef idx="3">
-            <a:schemeClr val="accent1"/>
-          </a:fillRef>
-          <a:effectRef idx="2">
-            <a:schemeClr val="accent1"/>
-          </a:effectRef>
-          <a:fontRef idx="minor">
-            <a:schemeClr val="lt1"/>
-          </a:fontRef>
-        </p:style>
-        <p:txBody>
-          <a:bodyPr rtlCol="0" anchor="ctr"/>
-          <a:lstStyle/>
-          <a:p>
-            <a:pPr algn="ctr"/>
-          </a:p>
-        </p:txBody>
-      </p:sp>
-      <p:sp>
-        <p:nvSpPr>
-          <p:cNvPr id="16" name="TextBox 15"/>
+          <p:cNvPr id="14" name="TextBox 13"/>
           <p:cNvSpPr txBox="1"/>
           <p:nvPr/>
         </p:nvSpPr>
         <p:spPr>
           <a:xfrm>
-            <a:off x="512064" y="2029968"/>
-            <a:ext cx="1152144" cy="640080"/>
-          </a:xfrm>
-          <a:prstGeom prst="rect">
-            <a:avLst/>
-          </a:prstGeom>
-          <a:noFill/>
-        </p:spPr>
-        <p:txBody>
-          <a:bodyPr wrap="square" lIns="18288" rIns="18288" tIns="0" bIns="0"/>
-          <a:lstStyle/>
-          <a:p>
-            <a:pPr algn="ctr">
-              <a:spcBef>
-                <a:spcPts val="0"/>
-              </a:spcBef>
-              <a:spcAft>
-                <a:spcPts val="0"/>
-              </a:spcAft>
-            </a:pPr>
-            <a:r>
-              <a:rPr sz="1600" b="1" i="0" lang="zh-CN" altLang="en-US">
-                <a:solidFill>
-                  <a:srgbClr val="8C6A2F"/>
-                </a:solidFill>
-                <a:latin typeface="微软雅黑"/>
-                <a:ea typeface="微软雅黑"/>
-                <a:cs typeface="微软雅黑"/>
-              </a:rPr>
-              <a:t>照片</a:t>
-            </a:r>
-          </a:p>
-          <a:p>
-            <a:pPr algn="ctr">
-              <a:spcBef>
-                <a:spcPts val="200"/>
-              </a:spcBef>
-              <a:spcAft>
-                <a:spcPts val="0"/>
-              </a:spcAft>
-            </a:pPr>
-            <a:r>
-              <a:rPr sz="1100" b="0" i="0" lang="zh-CN" altLang="en-US">
-                <a:solidFill>
-                  <a:srgbClr val="5E544C"/>
-                </a:solidFill>
-                <a:latin typeface="微软雅黑"/>
-                <a:ea typeface="微软雅黑"/>
-                <a:cs typeface="微软雅黑"/>
-              </a:rPr>
-              <a:t>一寸</a:t>
-            </a:r>
-          </a:p>
-        </p:txBody>
-      </p:sp>
-      <p:sp>
-        <p:nvSpPr>
-          <p:cNvPr id="17" name="TextBox 16"/>
-          <p:cNvSpPr txBox="1"/>
-          <p:nvPr/>
-        </p:nvSpPr>
-        <p:spPr>
-          <a:xfrm>
-            <a:off x="1810512" y="1627632"/>
-            <a:ext cx="2148840" cy="219456"/>
+            <a:off x="457200" y="1591056"/>
+            <a:ext cx="1005840" cy="219456"/>
           </a:xfrm>
           <a:prstGeom prst="rect">
             <a:avLst/>
@@ -4277,7 +4097,7 @@
               </a:spcAft>
             </a:pPr>
             <a:r>
-              <a:rPr sz="1100" b="1" i="0" lang="zh-CN" altLang="en-US">
+              <a:rPr sz="1200" b="1" i="0" lang="zh-CN" altLang="en-US">
                 <a:solidFill>
                   <a:srgbClr val="5E544C"/>
                 </a:solidFill>
@@ -4292,14 +4112,14 @@
       </p:sp>
       <p:sp>
         <p:nvSpPr>
-          <p:cNvPr id="18" name="TextBox 17"/>
+          <p:cNvPr id="15" name="TextBox 14"/>
           <p:cNvSpPr txBox="1"/>
           <p:nvPr/>
         </p:nvSpPr>
         <p:spPr>
           <a:xfrm>
-            <a:off x="1810512" y="1828800"/>
-            <a:ext cx="2148840" cy="384048"/>
+            <a:off x="1417320" y="1536192"/>
+            <a:ext cx="2514600" cy="365760"/>
           </a:xfrm>
           <a:prstGeom prst="rect">
             <a:avLst/>
@@ -4334,14 +4154,14 @@
       </p:sp>
       <p:sp>
         <p:nvSpPr>
-          <p:cNvPr id="19" name="Rectangle 18"/>
+          <p:cNvPr id="16" name="Rectangle 15"/>
           <p:cNvSpPr/>
           <p:nvPr/>
         </p:nvSpPr>
         <p:spPr>
           <a:xfrm>
-            <a:off x="1810512" y="2249424"/>
-            <a:ext cx="2011680" cy="13716"/>
+            <a:off x="1417320" y="1938528"/>
+            <a:ext cx="2331720" cy="13716"/>
           </a:xfrm>
           <a:prstGeom prst="rect">
             <a:avLst/>
@@ -4377,80 +4197,14 @@
       </p:sp>
       <p:sp>
         <p:nvSpPr>
-          <p:cNvPr id="20" name="TextBox 19"/>
+          <p:cNvPr id="17" name="TextBox 16"/>
           <p:cNvSpPr txBox="1"/>
           <p:nvPr/>
         </p:nvSpPr>
         <p:spPr>
           <a:xfrm>
-            <a:off x="1810512" y="2359152"/>
-            <a:ext cx="2194560" cy="640080"/>
-          </a:xfrm>
-          <a:prstGeom prst="rect">
-            <a:avLst/>
-          </a:prstGeom>
-          <a:noFill/>
-        </p:spPr>
-        <p:txBody>
-          <a:bodyPr wrap="square" lIns="18288" rIns="18288" tIns="0" bIns="0"/>
-          <a:lstStyle/>
-          <a:p>
-            <a:pPr algn="l">
-              <a:lnSpc>
-                <a:spcPct val="105000"/>
-              </a:lnSpc>
-              <a:spcBef>
-                <a:spcPts val="0"/>
-              </a:spcBef>
-              <a:spcAft>
-                <a:spcPts val="0"/>
-              </a:spcAft>
-            </a:pPr>
-            <a:r>
-              <a:rPr sz="1300" b="0" i="0" lang="zh-CN" altLang="en-US">
-                <a:solidFill>
-                  <a:srgbClr val="2C2622"/>
-                </a:solidFill>
-                <a:latin typeface="微软雅黑"/>
-                <a:ea typeface="微软雅黑"/>
-                <a:cs typeface="微软雅黑"/>
-              </a:rPr>
-              <a:t>申请加入</a:t>
-            </a:r>
-          </a:p>
-          <a:p>
-            <a:pPr algn="l">
-              <a:spcBef>
-                <a:spcPts val="100"/>
-              </a:spcBef>
-              <a:spcAft>
-                <a:spcPts val="0"/>
-              </a:spcAft>
-            </a:pPr>
-            <a:r>
-              <a:rPr sz="1300" b="1" i="0" lang="zh-CN" altLang="en-US">
-                <a:solidFill>
-                  <a:srgbClr val="8E1B2C"/>
-                </a:solidFill>
-                <a:latin typeface="微软雅黑"/>
-                <a:ea typeface="微软雅黑"/>
-                <a:cs typeface="微软雅黑"/>
-              </a:rPr>
-              <a:t>中国共产党</a:t>
-            </a:r>
-          </a:p>
-        </p:txBody>
-      </p:sp>
-      <p:sp>
-        <p:nvSpPr>
-          <p:cNvPr id="21" name="TextBox 20"/>
-          <p:cNvSpPr txBox="1"/>
-          <p:nvPr/>
-        </p:nvSpPr>
-        <p:spPr>
-          <a:xfrm>
-            <a:off x="457200" y="3273552"/>
-            <a:ext cx="438912" cy="256032"/>
+            <a:off x="457200" y="2084831"/>
+            <a:ext cx="457200" cy="274320"/>
           </a:xfrm>
           <a:prstGeom prst="rect">
             <a:avLst/>
@@ -4485,14 +4239,14 @@
       </p:sp>
       <p:sp>
         <p:nvSpPr>
-          <p:cNvPr id="22" name="TextBox 21"/>
+          <p:cNvPr id="18" name="TextBox 17"/>
           <p:cNvSpPr txBox="1"/>
           <p:nvPr/>
         </p:nvSpPr>
         <p:spPr>
           <a:xfrm>
-            <a:off x="896112" y="3273552"/>
-            <a:ext cx="1252728" cy="256032"/>
+            <a:off x="914400" y="2084831"/>
+            <a:ext cx="1280160" cy="274320"/>
           </a:xfrm>
           <a:prstGeom prst="rect">
             <a:avLst/>
@@ -4527,14 +4281,14 @@
       </p:sp>
       <p:sp>
         <p:nvSpPr>
-          <p:cNvPr id="23" name="Rectangle 22"/>
+          <p:cNvPr id="19" name="Rectangle 18"/>
           <p:cNvSpPr/>
           <p:nvPr/>
         </p:nvSpPr>
         <p:spPr>
           <a:xfrm>
-            <a:off x="896112" y="3529584"/>
-            <a:ext cx="1216152" cy="9144"/>
+            <a:off x="914400" y="2359151"/>
+            <a:ext cx="1243584" cy="9144"/>
           </a:xfrm>
           <a:prstGeom prst="rect">
             <a:avLst/>
@@ -4570,14 +4324,14 @@
       </p:sp>
       <p:sp>
         <p:nvSpPr>
-          <p:cNvPr id="24" name="TextBox 23"/>
+          <p:cNvPr id="20" name="TextBox 19"/>
           <p:cNvSpPr txBox="1"/>
           <p:nvPr/>
         </p:nvSpPr>
         <p:spPr>
           <a:xfrm>
-            <a:off x="2212848" y="3273552"/>
-            <a:ext cx="438912" cy="256032"/>
+            <a:off x="2212848" y="2084831"/>
+            <a:ext cx="457200" cy="274320"/>
           </a:xfrm>
           <a:prstGeom prst="rect">
             <a:avLst/>
@@ -4612,14 +4366,14 @@
       </p:sp>
       <p:sp>
         <p:nvSpPr>
-          <p:cNvPr id="25" name="TextBox 24"/>
+          <p:cNvPr id="21" name="TextBox 20"/>
           <p:cNvSpPr txBox="1"/>
           <p:nvPr/>
         </p:nvSpPr>
         <p:spPr>
           <a:xfrm>
-            <a:off x="2651760" y="3273552"/>
-            <a:ext cx="1344168" cy="256032"/>
+            <a:off x="2670048" y="2084831"/>
+            <a:ext cx="1325880" cy="274320"/>
           </a:xfrm>
           <a:prstGeom prst="rect">
             <a:avLst/>
@@ -4654,14 +4408,14 @@
       </p:sp>
       <p:sp>
         <p:nvSpPr>
-          <p:cNvPr id="26" name="Rectangle 25"/>
+          <p:cNvPr id="22" name="Rectangle 21"/>
           <p:cNvSpPr/>
           <p:nvPr/>
         </p:nvSpPr>
         <p:spPr>
           <a:xfrm>
-            <a:off x="2651760" y="3529584"/>
-            <a:ext cx="1307592" cy="9144"/>
+            <a:off x="2670048" y="2359151"/>
+            <a:ext cx="1289304" cy="9144"/>
           </a:xfrm>
           <a:prstGeom prst="rect">
             <a:avLst/>
@@ -4697,14 +4451,14 @@
       </p:sp>
       <p:sp>
         <p:nvSpPr>
-          <p:cNvPr id="27" name="TextBox 26"/>
+          <p:cNvPr id="23" name="TextBox 22"/>
           <p:cNvSpPr txBox="1"/>
           <p:nvPr/>
         </p:nvSpPr>
         <p:spPr>
           <a:xfrm>
-            <a:off x="457200" y="3694176"/>
-            <a:ext cx="438912" cy="256032"/>
+            <a:off x="457200" y="2450592"/>
+            <a:ext cx="457200" cy="274320"/>
           </a:xfrm>
           <a:prstGeom prst="rect">
             <a:avLst/>
@@ -4732,21 +4486,21 @@
                 <a:ea typeface="微软雅黑"/>
                 <a:cs typeface="微软雅黑"/>
               </a:rPr>
-              <a:t>出生</a:t>
-            </a:r>
-          </a:p>
-        </p:txBody>
-      </p:sp>
-      <p:sp>
-        <p:nvSpPr>
-          <p:cNvPr id="28" name="TextBox 27"/>
+              <a:t>专业</a:t>
+            </a:r>
+          </a:p>
+        </p:txBody>
+      </p:sp>
+      <p:sp>
+        <p:nvSpPr>
+          <p:cNvPr id="24" name="TextBox 23"/>
           <p:cNvSpPr txBox="1"/>
           <p:nvPr/>
         </p:nvSpPr>
         <p:spPr>
           <a:xfrm>
-            <a:off x="896112" y="3694176"/>
-            <a:ext cx="1252728" cy="256032"/>
+            <a:off x="914400" y="2450592"/>
+            <a:ext cx="1280160" cy="274320"/>
           </a:xfrm>
           <a:prstGeom prst="rect">
             <a:avLst/>
@@ -4781,14 +4535,14 @@
       </p:sp>
       <p:sp>
         <p:nvSpPr>
-          <p:cNvPr id="29" name="Rectangle 28"/>
+          <p:cNvPr id="25" name="Rectangle 24"/>
           <p:cNvSpPr/>
           <p:nvPr/>
         </p:nvSpPr>
         <p:spPr>
           <a:xfrm>
-            <a:off x="896112" y="3950208"/>
-            <a:ext cx="1216152" cy="9144"/>
+            <a:off x="914400" y="2724912"/>
+            <a:ext cx="1243584" cy="9144"/>
           </a:xfrm>
           <a:prstGeom prst="rect">
             <a:avLst/>
@@ -4824,14 +4578,14 @@
       </p:sp>
       <p:sp>
         <p:nvSpPr>
-          <p:cNvPr id="30" name="TextBox 29"/>
+          <p:cNvPr id="26" name="TextBox 25"/>
           <p:cNvSpPr txBox="1"/>
           <p:nvPr/>
         </p:nvSpPr>
         <p:spPr>
           <a:xfrm>
-            <a:off x="2212848" y="3694176"/>
-            <a:ext cx="438912" cy="256032"/>
+            <a:off x="2212848" y="2450592"/>
+            <a:ext cx="457200" cy="274320"/>
           </a:xfrm>
           <a:prstGeom prst="rect">
             <a:avLst/>
@@ -4859,21 +4613,21 @@
                 <a:ea typeface="微软雅黑"/>
                 <a:cs typeface="微软雅黑"/>
               </a:rPr>
-              <a:t>籍贯</a:t>
-            </a:r>
-          </a:p>
-        </p:txBody>
-      </p:sp>
-      <p:sp>
-        <p:nvSpPr>
-          <p:cNvPr id="31" name="TextBox 30"/>
+              <a:t>面貌</a:t>
+            </a:r>
+          </a:p>
+        </p:txBody>
+      </p:sp>
+      <p:sp>
+        <p:nvSpPr>
+          <p:cNvPr id="27" name="TextBox 26"/>
           <p:cNvSpPr txBox="1"/>
           <p:nvPr/>
         </p:nvSpPr>
         <p:spPr>
           <a:xfrm>
-            <a:off x="2651760" y="3694176"/>
-            <a:ext cx="1344168" cy="256032"/>
+            <a:off x="2670048" y="2450592"/>
+            <a:ext cx="1325880" cy="274320"/>
           </a:xfrm>
           <a:prstGeom prst="rect">
             <a:avLst/>
@@ -4895,27 +4649,27 @@
             <a:r>
               <a:rPr sz="1300" b="1" i="0" lang="zh-CN" altLang="en-US">
                 <a:solidFill>
-                  <a:srgbClr val="8B2E32"/>
+                  <a:srgbClr val="2C2622"/>
                 </a:solidFill>
                 <a:latin typeface="微软雅黑"/>
                 <a:ea typeface="微软雅黑"/>
                 <a:cs typeface="微软雅黑"/>
               </a:rPr>
-              <a:t>请填写</a:t>
-            </a:r>
-          </a:p>
-        </p:txBody>
-      </p:sp>
-      <p:sp>
-        <p:nvSpPr>
-          <p:cNvPr id="32" name="Rectangle 31"/>
+              <a:t>中共党员</a:t>
+            </a:r>
+          </a:p>
+        </p:txBody>
+      </p:sp>
+      <p:sp>
+        <p:nvSpPr>
+          <p:cNvPr id="28" name="Rectangle 27"/>
           <p:cNvSpPr/>
           <p:nvPr/>
         </p:nvSpPr>
         <p:spPr>
           <a:xfrm>
-            <a:off x="2651760" y="3950208"/>
-            <a:ext cx="1307592" cy="9144"/>
+            <a:off x="2670048" y="2724912"/>
+            <a:ext cx="1289304" cy="9144"/>
           </a:xfrm>
           <a:prstGeom prst="rect">
             <a:avLst/>
@@ -4951,14 +4705,102 @@
       </p:sp>
       <p:sp>
         <p:nvSpPr>
-          <p:cNvPr id="33" name="TextBox 32"/>
+          <p:cNvPr id="29" name="Rounded Rectangle 28"/>
+          <p:cNvSpPr/>
+          <p:nvPr/>
+        </p:nvSpPr>
+        <p:spPr>
+          <a:xfrm>
+            <a:off x="438912" y="2907792"/>
+            <a:ext cx="3566160" cy="1627632"/>
+          </a:xfrm>
+          <a:prstGeom prst="roundRect">
+            <a:avLst>
+              <a:gd name="adj" fmla="val 8000"/>
+            </a:avLst>
+          </a:prstGeom>
+          <a:solidFill>
+            <a:srgbClr val="F8EFEA"/>
+          </a:solidFill>
+          <a:ln>
+            <a:noFill/>
+          </a:ln>
+        </p:spPr>
+        <p:style>
+          <a:lnRef idx="1">
+            <a:schemeClr val="accent1"/>
+          </a:lnRef>
+          <a:fillRef idx="3">
+            <a:schemeClr val="accent1"/>
+          </a:fillRef>
+          <a:effectRef idx="2">
+            <a:schemeClr val="accent1"/>
+          </a:effectRef>
+          <a:fontRef idx="minor">
+            <a:schemeClr val="lt1"/>
+          </a:fontRef>
+        </p:style>
+        <p:txBody>
+          <a:bodyPr rtlCol="0" anchor="ctr"/>
+          <a:lstStyle/>
+          <a:p>
+            <a:pPr algn="ctr"/>
+          </a:p>
+        </p:txBody>
+      </p:sp>
+      <p:sp>
+        <p:nvSpPr>
+          <p:cNvPr id="30" name="Rectangle 29"/>
+          <p:cNvSpPr/>
+          <p:nvPr/>
+        </p:nvSpPr>
+        <p:spPr>
+          <a:xfrm>
+            <a:off x="438912" y="2907792"/>
+            <a:ext cx="73152" cy="1627632"/>
+          </a:xfrm>
+          <a:prstGeom prst="rect">
+            <a:avLst/>
+          </a:prstGeom>
+          <a:solidFill>
+            <a:srgbClr val="8E1B2C"/>
+          </a:solidFill>
+          <a:ln>
+            <a:noFill/>
+          </a:ln>
+        </p:spPr>
+        <p:style>
+          <a:lnRef idx="1">
+            <a:schemeClr val="accent1"/>
+          </a:lnRef>
+          <a:fillRef idx="3">
+            <a:schemeClr val="accent1"/>
+          </a:fillRef>
+          <a:effectRef idx="2">
+            <a:schemeClr val="accent1"/>
+          </a:effectRef>
+          <a:fontRef idx="minor">
+            <a:schemeClr val="lt1"/>
+          </a:fontRef>
+        </p:style>
+        <p:txBody>
+          <a:bodyPr rtlCol="0" anchor="ctr"/>
+          <a:lstStyle/>
+          <a:p>
+            <a:pPr algn="ctr"/>
+          </a:p>
+        </p:txBody>
+      </p:sp>
+      <p:sp>
+        <p:nvSpPr>
+          <p:cNvPr id="31" name="TextBox 30"/>
           <p:cNvSpPr txBox="1"/>
           <p:nvPr/>
         </p:nvSpPr>
         <p:spPr>
           <a:xfrm>
-            <a:off x="457200" y="4114800"/>
-            <a:ext cx="438912" cy="256032"/>
+            <a:off x="640080" y="2980944"/>
+            <a:ext cx="3200400" cy="274320"/>
           </a:xfrm>
           <a:prstGeom prst="rect">
             <a:avLst/>
@@ -4978,6 +4820,48 @@
               </a:spcAft>
             </a:pPr>
             <a:r>
+              <a:rPr sz="1400" b="1" i="0" lang="zh-CN" altLang="en-US">
+                <a:solidFill>
+                  <a:srgbClr val="6E1422"/>
+                </a:solidFill>
+                <a:latin typeface="微软雅黑"/>
+                <a:ea typeface="微软雅黑"/>
+                <a:cs typeface="微软雅黑"/>
+              </a:rPr>
+              <a:t>党内经历</a:t>
+            </a:r>
+          </a:p>
+        </p:txBody>
+      </p:sp>
+      <p:sp>
+        <p:nvSpPr>
+          <p:cNvPr id="32" name="TextBox 31"/>
+          <p:cNvSpPr txBox="1"/>
+          <p:nvPr/>
+        </p:nvSpPr>
+        <p:spPr>
+          <a:xfrm>
+            <a:off x="640080" y="3291840"/>
+            <a:ext cx="960120" cy="274320"/>
+          </a:xfrm>
+          <a:prstGeom prst="rect">
+            <a:avLst/>
+          </a:prstGeom>
+          <a:noFill/>
+        </p:spPr>
+        <p:txBody>
+          <a:bodyPr wrap="square" lIns="18288" rIns="18288" tIns="0" bIns="0"/>
+          <a:lstStyle/>
+          <a:p>
+            <a:pPr algn="l">
+              <a:spcBef>
+                <a:spcPts val="0"/>
+              </a:spcBef>
+              <a:spcAft>
+                <a:spcPts val="0"/>
+              </a:spcAft>
+            </a:pPr>
+            <a:r>
               <a:rPr sz="1200" b="1" i="0" lang="zh-CN" altLang="en-US">
                 <a:solidFill>
                   <a:srgbClr val="5E544C"/>
@@ -4986,21 +4870,21 @@
                 <a:ea typeface="微软雅黑"/>
                 <a:cs typeface="微软雅黑"/>
               </a:rPr>
-              <a:t>专业</a:t>
-            </a:r>
-          </a:p>
-        </p:txBody>
-      </p:sp>
-      <p:sp>
-        <p:nvSpPr>
-          <p:cNvPr id="34" name="TextBox 33"/>
+              <a:t>入党时间</a:t>
+            </a:r>
+          </a:p>
+        </p:txBody>
+      </p:sp>
+      <p:sp>
+        <p:nvSpPr>
+          <p:cNvPr id="33" name="TextBox 32"/>
           <p:cNvSpPr txBox="1"/>
           <p:nvPr/>
         </p:nvSpPr>
         <p:spPr>
           <a:xfrm>
-            <a:off x="896112" y="4114800"/>
-            <a:ext cx="1252728" cy="256032"/>
+            <a:off x="1600200" y="3291840"/>
+            <a:ext cx="2240280" cy="274320"/>
           </a:xfrm>
           <a:prstGeom prst="rect">
             <a:avLst/>
@@ -5020,7 +4904,7 @@
               </a:spcAft>
             </a:pPr>
             <a:r>
-              <a:rPr sz="1300" b="1" i="0" lang="zh-CN" altLang="en-US">
+              <a:rPr sz="1600" b="1" i="0" lang="zh-CN" altLang="en-US">
                 <a:solidFill>
                   <a:srgbClr val="8B2E32"/>
                 </a:solidFill>
@@ -5035,14 +4919,14 @@
       </p:sp>
       <p:sp>
         <p:nvSpPr>
-          <p:cNvPr id="35" name="Rectangle 34"/>
+          <p:cNvPr id="34" name="Rectangle 33"/>
           <p:cNvSpPr/>
           <p:nvPr/>
         </p:nvSpPr>
         <p:spPr>
           <a:xfrm>
-            <a:off x="896112" y="4370832"/>
-            <a:ext cx="1216152" cy="9144"/>
+            <a:off x="1600200" y="3566160"/>
+            <a:ext cx="2203704" cy="9144"/>
           </a:xfrm>
           <a:prstGeom prst="rect">
             <a:avLst/>
@@ -5078,14 +4962,14 @@
       </p:sp>
       <p:sp>
         <p:nvSpPr>
-          <p:cNvPr id="36" name="TextBox 35"/>
+          <p:cNvPr id="35" name="TextBox 34"/>
           <p:cNvSpPr txBox="1"/>
           <p:nvPr/>
         </p:nvSpPr>
         <p:spPr>
           <a:xfrm>
-            <a:off x="2212848" y="4114800"/>
-            <a:ext cx="713232" cy="256032"/>
+            <a:off x="640080" y="3694176"/>
+            <a:ext cx="960120" cy="274320"/>
           </a:xfrm>
           <a:prstGeom prst="rect">
             <a:avLst/>
@@ -5113,21 +4997,21 @@
                 <a:ea typeface="微软雅黑"/>
                 <a:cs typeface="微软雅黑"/>
               </a:rPr>
-              <a:t>政治面貌</a:t>
-            </a:r>
-          </a:p>
-        </p:txBody>
-      </p:sp>
-      <p:sp>
-        <p:nvSpPr>
-          <p:cNvPr id="37" name="TextBox 36"/>
+              <a:t>转正时间</a:t>
+            </a:r>
+          </a:p>
+        </p:txBody>
+      </p:sp>
+      <p:sp>
+        <p:nvSpPr>
+          <p:cNvPr id="36" name="TextBox 35"/>
           <p:cNvSpPr txBox="1"/>
           <p:nvPr/>
         </p:nvSpPr>
         <p:spPr>
           <a:xfrm>
-            <a:off x="2926080" y="4114800"/>
-            <a:ext cx="1069848" cy="256032"/>
+            <a:off x="1600200" y="3694176"/>
+            <a:ext cx="2240280" cy="274320"/>
           </a:xfrm>
           <a:prstGeom prst="rect">
             <a:avLst/>
@@ -5147,7 +5031,7 @@
               </a:spcAft>
             </a:pPr>
             <a:r>
-              <a:rPr sz="1300" b="1" i="0" lang="zh-CN" altLang="en-US">
+              <a:rPr sz="1600" b="1" i="0" lang="zh-CN" altLang="en-US">
                 <a:solidFill>
                   <a:srgbClr val="8B2E32"/>
                 </a:solidFill>
@@ -5162,14 +5046,14 @@
       </p:sp>
       <p:sp>
         <p:nvSpPr>
-          <p:cNvPr id="38" name="Rectangle 37"/>
+          <p:cNvPr id="37" name="Rectangle 36"/>
           <p:cNvSpPr/>
           <p:nvPr/>
         </p:nvSpPr>
         <p:spPr>
           <a:xfrm>
-            <a:off x="2926080" y="4370832"/>
-            <a:ext cx="1033271" cy="9144"/>
+            <a:off x="1600200" y="3968496"/>
+            <a:ext cx="2203704" cy="9144"/>
           </a:xfrm>
           <a:prstGeom prst="rect">
             <a:avLst/>
@@ -5205,147 +5089,14 @@
       </p:sp>
       <p:sp>
         <p:nvSpPr>
-          <p:cNvPr id="39" name="Rounded Rectangle 38"/>
-          <p:cNvSpPr/>
-          <p:nvPr/>
-        </p:nvSpPr>
-        <p:spPr>
-          <a:xfrm>
-            <a:off x="4325112" y="1147572"/>
-            <a:ext cx="7589520" cy="1755648"/>
-          </a:xfrm>
-          <a:prstGeom prst="roundRect">
-            <a:avLst>
-              <a:gd name="adj" fmla="val 5000"/>
-            </a:avLst>
-          </a:prstGeom>
-          <a:solidFill>
-            <a:srgbClr val="E3D9CE"/>
-          </a:solidFill>
-          <a:ln>
-            <a:noFill/>
-          </a:ln>
-        </p:spPr>
-        <p:style>
-          <a:lnRef idx="1">
-            <a:schemeClr val="accent1"/>
-          </a:lnRef>
-          <a:fillRef idx="3">
-            <a:schemeClr val="accent1"/>
-          </a:fillRef>
-          <a:effectRef idx="2">
-            <a:schemeClr val="accent1"/>
-          </a:effectRef>
-          <a:fontRef idx="minor">
-            <a:schemeClr val="lt1"/>
-          </a:fontRef>
-        </p:style>
-        <p:txBody>
-          <a:bodyPr rtlCol="0" anchor="ctr"/>
-          <a:lstStyle/>
-          <a:p>
-            <a:pPr algn="ctr"/>
-          </a:p>
-        </p:txBody>
-      </p:sp>
-      <p:sp>
-        <p:nvSpPr>
-          <p:cNvPr id="40" name="Rounded Rectangle 39"/>
-          <p:cNvSpPr/>
-          <p:nvPr/>
-        </p:nvSpPr>
-        <p:spPr>
-          <a:xfrm>
-            <a:off x="4297680" y="1115568"/>
-            <a:ext cx="7589520" cy="1755648"/>
-          </a:xfrm>
-          <a:prstGeom prst="roundRect">
-            <a:avLst>
-              <a:gd name="adj" fmla="val 5000"/>
-            </a:avLst>
-          </a:prstGeom>
-          <a:solidFill>
-            <a:srgbClr val="FFFCF8"/>
-          </a:solidFill>
-          <a:ln>
-            <a:noFill/>
-          </a:ln>
-        </p:spPr>
-        <p:style>
-          <a:lnRef idx="1">
-            <a:schemeClr val="accent1"/>
-          </a:lnRef>
-          <a:fillRef idx="3">
-            <a:schemeClr val="accent1"/>
-          </a:fillRef>
-          <a:effectRef idx="2">
-            <a:schemeClr val="accent1"/>
-          </a:effectRef>
-          <a:fontRef idx="minor">
-            <a:schemeClr val="lt1"/>
-          </a:fontRef>
-        </p:style>
-        <p:txBody>
-          <a:bodyPr rtlCol="0" anchor="ctr"/>
-          <a:lstStyle/>
-          <a:p>
-            <a:pPr algn="ctr"/>
-          </a:p>
-        </p:txBody>
-      </p:sp>
-      <p:sp>
-        <p:nvSpPr>
-          <p:cNvPr id="41" name="Rectangle 40"/>
-          <p:cNvSpPr/>
-          <p:nvPr/>
-        </p:nvSpPr>
-        <p:spPr>
-          <a:xfrm>
-            <a:off x="4480560" y="1271016"/>
-            <a:ext cx="68580" cy="201168"/>
-          </a:xfrm>
-          <a:prstGeom prst="rect">
-            <a:avLst/>
-          </a:prstGeom>
-          <a:solidFill>
-            <a:srgbClr val="8E1B2C"/>
-          </a:solidFill>
-          <a:ln>
-            <a:noFill/>
-          </a:ln>
-        </p:spPr>
-        <p:style>
-          <a:lnRef idx="1">
-            <a:schemeClr val="accent1"/>
-          </a:lnRef>
-          <a:fillRef idx="3">
-            <a:schemeClr val="accent1"/>
-          </a:fillRef>
-          <a:effectRef idx="2">
-            <a:schemeClr val="accent1"/>
-          </a:effectRef>
-          <a:fontRef idx="minor">
-            <a:schemeClr val="lt1"/>
-          </a:fontRef>
-        </p:style>
-        <p:txBody>
-          <a:bodyPr rtlCol="0" anchor="ctr"/>
-          <a:lstStyle/>
-          <a:p>
-            <a:pPr algn="ctr"/>
-          </a:p>
-        </p:txBody>
-      </p:sp>
-      <p:sp>
-        <p:nvSpPr>
-          <p:cNvPr id="42" name="TextBox 41"/>
+          <p:cNvPr id="38" name="TextBox 37"/>
           <p:cNvSpPr txBox="1"/>
           <p:nvPr/>
         </p:nvSpPr>
         <p:spPr>
           <a:xfrm>
-            <a:off x="4608576" y="1225296"/>
-            <a:ext cx="7095744" cy="310896"/>
+            <a:off x="640080" y="4096512"/>
+            <a:ext cx="960120" cy="274320"/>
           </a:xfrm>
           <a:prstGeom prst="rect">
             <a:avLst/>
@@ -5365,6 +5116,266 @@
               </a:spcAft>
             </a:pPr>
             <a:r>
+              <a:rPr sz="1200" b="1" i="0" lang="zh-CN" altLang="en-US">
+                <a:solidFill>
+                  <a:srgbClr val="5E544C"/>
+                </a:solidFill>
+                <a:latin typeface="微软雅黑"/>
+                <a:ea typeface="微软雅黑"/>
+                <a:cs typeface="微软雅黑"/>
+              </a:rPr>
+              <a:t>曾任职务</a:t>
+            </a:r>
+          </a:p>
+        </p:txBody>
+      </p:sp>
+      <p:sp>
+        <p:nvSpPr>
+          <p:cNvPr id="39" name="TextBox 38"/>
+          <p:cNvSpPr txBox="1"/>
+          <p:nvPr/>
+        </p:nvSpPr>
+        <p:spPr>
+          <a:xfrm>
+            <a:off x="1600200" y="4096512"/>
+            <a:ext cx="2240280" cy="274320"/>
+          </a:xfrm>
+          <a:prstGeom prst="rect">
+            <a:avLst/>
+          </a:prstGeom>
+          <a:noFill/>
+        </p:spPr>
+        <p:txBody>
+          <a:bodyPr wrap="square" lIns="18288" rIns="18288" tIns="0" bIns="0"/>
+          <a:lstStyle/>
+          <a:p>
+            <a:pPr algn="l">
+              <a:spcBef>
+                <a:spcPts val="0"/>
+              </a:spcBef>
+              <a:spcAft>
+                <a:spcPts val="0"/>
+              </a:spcAft>
+            </a:pPr>
+            <a:r>
+              <a:rPr sz="1600" b="1" i="0" lang="zh-CN" altLang="en-US">
+                <a:solidFill>
+                  <a:srgbClr val="8E1B2C"/>
+                </a:solidFill>
+                <a:latin typeface="微软雅黑"/>
+                <a:ea typeface="微软雅黑"/>
+                <a:cs typeface="微软雅黑"/>
+              </a:rPr>
+              <a:t>班级组织委员</a:t>
+            </a:r>
+          </a:p>
+        </p:txBody>
+      </p:sp>
+      <p:sp>
+        <p:nvSpPr>
+          <p:cNvPr id="40" name="Rectangle 39"/>
+          <p:cNvSpPr/>
+          <p:nvPr/>
+        </p:nvSpPr>
+        <p:spPr>
+          <a:xfrm>
+            <a:off x="1600200" y="4370832"/>
+            <a:ext cx="2203704" cy="9144"/>
+          </a:xfrm>
+          <a:prstGeom prst="rect">
+            <a:avLst/>
+          </a:prstGeom>
+          <a:solidFill>
+            <a:srgbClr val="E4D9CC"/>
+          </a:solidFill>
+          <a:ln>
+            <a:noFill/>
+          </a:ln>
+        </p:spPr>
+        <p:style>
+          <a:lnRef idx="1">
+            <a:schemeClr val="accent1"/>
+          </a:lnRef>
+          <a:fillRef idx="3">
+            <a:schemeClr val="accent1"/>
+          </a:fillRef>
+          <a:effectRef idx="2">
+            <a:schemeClr val="accent1"/>
+          </a:effectRef>
+          <a:fontRef idx="minor">
+            <a:schemeClr val="lt1"/>
+          </a:fontRef>
+        </p:style>
+        <p:txBody>
+          <a:bodyPr rtlCol="0" anchor="ctr"/>
+          <a:lstStyle/>
+          <a:p>
+            <a:pPr algn="ctr"/>
+          </a:p>
+        </p:txBody>
+      </p:sp>
+      <p:sp>
+        <p:nvSpPr>
+          <p:cNvPr id="41" name="Rounded Rectangle 40"/>
+          <p:cNvSpPr/>
+          <p:nvPr/>
+        </p:nvSpPr>
+        <p:spPr>
+          <a:xfrm>
+            <a:off x="4325112" y="1147572"/>
+            <a:ext cx="7589520" cy="1755648"/>
+          </a:xfrm>
+          <a:prstGeom prst="roundRect">
+            <a:avLst>
+              <a:gd name="adj" fmla="val 5000"/>
+            </a:avLst>
+          </a:prstGeom>
+          <a:solidFill>
+            <a:srgbClr val="E3D9CE"/>
+          </a:solidFill>
+          <a:ln>
+            <a:noFill/>
+          </a:ln>
+        </p:spPr>
+        <p:style>
+          <a:lnRef idx="1">
+            <a:schemeClr val="accent1"/>
+          </a:lnRef>
+          <a:fillRef idx="3">
+            <a:schemeClr val="accent1"/>
+          </a:fillRef>
+          <a:effectRef idx="2">
+            <a:schemeClr val="accent1"/>
+          </a:effectRef>
+          <a:fontRef idx="minor">
+            <a:schemeClr val="lt1"/>
+          </a:fontRef>
+        </p:style>
+        <p:txBody>
+          <a:bodyPr rtlCol="0" anchor="ctr"/>
+          <a:lstStyle/>
+          <a:p>
+            <a:pPr algn="ctr"/>
+          </a:p>
+        </p:txBody>
+      </p:sp>
+      <p:sp>
+        <p:nvSpPr>
+          <p:cNvPr id="42" name="Rounded Rectangle 41"/>
+          <p:cNvSpPr/>
+          <p:nvPr/>
+        </p:nvSpPr>
+        <p:spPr>
+          <a:xfrm>
+            <a:off x="4297680" y="1115568"/>
+            <a:ext cx="7589520" cy="1755648"/>
+          </a:xfrm>
+          <a:prstGeom prst="roundRect">
+            <a:avLst>
+              <a:gd name="adj" fmla="val 5000"/>
+            </a:avLst>
+          </a:prstGeom>
+          <a:solidFill>
+            <a:srgbClr val="FFFCF8"/>
+          </a:solidFill>
+          <a:ln>
+            <a:noFill/>
+          </a:ln>
+        </p:spPr>
+        <p:style>
+          <a:lnRef idx="1">
+            <a:schemeClr val="accent1"/>
+          </a:lnRef>
+          <a:fillRef idx="3">
+            <a:schemeClr val="accent1"/>
+          </a:fillRef>
+          <a:effectRef idx="2">
+            <a:schemeClr val="accent1"/>
+          </a:effectRef>
+          <a:fontRef idx="minor">
+            <a:schemeClr val="lt1"/>
+          </a:fontRef>
+        </p:style>
+        <p:txBody>
+          <a:bodyPr rtlCol="0" anchor="ctr"/>
+          <a:lstStyle/>
+          <a:p>
+            <a:pPr algn="ctr"/>
+          </a:p>
+        </p:txBody>
+      </p:sp>
+      <p:sp>
+        <p:nvSpPr>
+          <p:cNvPr id="43" name="Rectangle 42"/>
+          <p:cNvSpPr/>
+          <p:nvPr/>
+        </p:nvSpPr>
+        <p:spPr>
+          <a:xfrm>
+            <a:off x="4480560" y="1271016"/>
+            <a:ext cx="68580" cy="201168"/>
+          </a:xfrm>
+          <a:prstGeom prst="rect">
+            <a:avLst/>
+          </a:prstGeom>
+          <a:solidFill>
+            <a:srgbClr val="8E1B2C"/>
+          </a:solidFill>
+          <a:ln>
+            <a:noFill/>
+          </a:ln>
+        </p:spPr>
+        <p:style>
+          <a:lnRef idx="1">
+            <a:schemeClr val="accent1"/>
+          </a:lnRef>
+          <a:fillRef idx="3">
+            <a:schemeClr val="accent1"/>
+          </a:fillRef>
+          <a:effectRef idx="2">
+            <a:schemeClr val="accent1"/>
+          </a:effectRef>
+          <a:fontRef idx="minor">
+            <a:schemeClr val="lt1"/>
+          </a:fontRef>
+        </p:style>
+        <p:txBody>
+          <a:bodyPr rtlCol="0" anchor="ctr"/>
+          <a:lstStyle/>
+          <a:p>
+            <a:pPr algn="ctr"/>
+          </a:p>
+        </p:txBody>
+      </p:sp>
+      <p:sp>
+        <p:nvSpPr>
+          <p:cNvPr id="44" name="TextBox 43"/>
+          <p:cNvSpPr txBox="1"/>
+          <p:nvPr/>
+        </p:nvSpPr>
+        <p:spPr>
+          <a:xfrm>
+            <a:off x="4608576" y="1225296"/>
+            <a:ext cx="7095744" cy="310896"/>
+          </a:xfrm>
+          <a:prstGeom prst="rect">
+            <a:avLst/>
+          </a:prstGeom>
+          <a:noFill/>
+        </p:spPr>
+        <p:txBody>
+          <a:bodyPr wrap="square" lIns="18288" rIns="18288" tIns="0" bIns="0"/>
+          <a:lstStyle/>
+          <a:p>
+            <a:pPr algn="l">
+              <a:spcBef>
+                <a:spcPts val="0"/>
+              </a:spcBef>
+              <a:spcAft>
+                <a:spcPts val="0"/>
+              </a:spcAft>
+            </a:pPr>
+            <a:r>
               <a:rPr sz="1600" b="1" i="0" lang="zh-CN" altLang="en-US">
                 <a:solidFill>
                   <a:srgbClr val="6E1422"/>
@@ -5373,14 +5384,14 @@
                 <a:ea typeface="微软雅黑"/>
                 <a:cs typeface="微软雅黑"/>
               </a:rPr>
-              <a:t>二、对党的认识</a:t>
-            </a:r>
-          </a:p>
-        </p:txBody>
-      </p:sp>
-      <p:sp>
-        <p:nvSpPr>
-          <p:cNvPr id="43" name="TextBox 42"/>
+              <a:t>二、曾任班级组织委员</a:t>
+            </a:r>
+          </a:p>
+        </p:txBody>
+      </p:sp>
+      <p:sp>
+        <p:nvSpPr>
+          <p:cNvPr id="45" name="TextBox 44"/>
           <p:cNvSpPr txBox="1"/>
           <p:nvPr/>
         </p:nvSpPr>
@@ -5397,78 +5408,6 @@
         <p:txBody>
           <a:bodyPr wrap="square" lIns="18288" rIns="18288" tIns="0" bIns="0"/>
           <a:lstStyle/>
-          <a:p>
-            <a:pPr algn="l">
-              <a:lnSpc>
-                <a:spcPct val="112000"/>
-              </a:lnSpc>
-              <a:spcBef>
-                <a:spcPts val="0"/>
-              </a:spcBef>
-              <a:spcAft>
-                <a:spcPts val="0"/>
-              </a:spcAft>
-            </a:pPr>
-            <a:r>
-              <a:rPr sz="1500" b="0" i="0" lang="zh-CN" altLang="en-US">
-                <a:solidFill>
-                  <a:srgbClr val="2C2622"/>
-                </a:solidFill>
-                <a:latin typeface="微软雅黑"/>
-                <a:ea typeface="微软雅黑"/>
-                <a:cs typeface="微软雅黑"/>
-              </a:rPr>
-              <a:t>中国共产党是中国工人阶级的先锋队，同时是中国人民和中华民族的先锋队。</a:t>
-            </a:r>
-          </a:p>
-          <a:p>
-            <a:pPr algn="l">
-              <a:lnSpc>
-                <a:spcPct val="112000"/>
-              </a:lnSpc>
-              <a:spcBef>
-                <a:spcPts val="100"/>
-              </a:spcBef>
-              <a:spcAft>
-                <a:spcPts val="0"/>
-              </a:spcAft>
-            </a:pPr>
-            <a:r>
-              <a:rPr sz="1500" b="0" i="0" lang="zh-CN" altLang="en-US">
-                <a:solidFill>
-                  <a:srgbClr val="2C2622"/>
-                </a:solidFill>
-                <a:latin typeface="微软雅黑"/>
-                <a:ea typeface="微软雅黑"/>
-                <a:cs typeface="微软雅黑"/>
-              </a:rPr>
-              <a:t>党的初心和使命，是为中国人民谋幸福、为中华民族谋复兴。</a:t>
-            </a:r>
-          </a:p>
-          <a:p>
-            <a:pPr algn="l">
-              <a:lnSpc>
-                <a:spcPct val="108000"/>
-              </a:lnSpc>
-              <a:spcBef>
-                <a:spcPts val="100"/>
-              </a:spcBef>
-              <a:spcAft>
-                <a:spcPts val="0"/>
-              </a:spcAft>
-            </a:pPr>
-            <a:r>
-              <a:rPr sz="1500" b="0" i="0" lang="zh-CN" altLang="en-US">
-                <a:solidFill>
-                  <a:srgbClr val="2C2622"/>
-                </a:solidFill>
-                <a:latin typeface="微软雅黑"/>
-                <a:ea typeface="微软雅黑"/>
-                <a:cs typeface="微软雅黑"/>
-              </a:rPr>
-              <a:t>入党是郑重的政治选择。我愿在思想上认同，在行动上靠拢，</a:t>
-            </a:r>
-          </a:p>
           <a:p>
             <a:pPr algn="l">
               <a:lnSpc>
@@ -5490,209 +5429,13 @@
                 <a:ea typeface="微软雅黑"/>
                 <a:cs typeface="微软雅黑"/>
               </a:rPr>
-              <a:t>并长期接受组织的教育和考验。</a:t>
-            </a:r>
-          </a:p>
-        </p:txBody>
-      </p:sp>
-      <p:sp>
-        <p:nvSpPr>
-          <p:cNvPr id="44" name="Rounded Rectangle 43"/>
-          <p:cNvSpPr/>
-          <p:nvPr/>
-        </p:nvSpPr>
-        <p:spPr>
-          <a:xfrm>
-            <a:off x="4325112" y="3012948"/>
-            <a:ext cx="7589520" cy="1719072"/>
-          </a:xfrm>
-          <a:prstGeom prst="roundRect">
-            <a:avLst>
-              <a:gd name="adj" fmla="val 5000"/>
-            </a:avLst>
-          </a:prstGeom>
-          <a:solidFill>
-            <a:srgbClr val="E3D9CE"/>
-          </a:solidFill>
-          <a:ln>
-            <a:noFill/>
-          </a:ln>
-        </p:spPr>
-        <p:style>
-          <a:lnRef idx="1">
-            <a:schemeClr val="accent1"/>
-          </a:lnRef>
-          <a:fillRef idx="3">
-            <a:schemeClr val="accent1"/>
-          </a:fillRef>
-          <a:effectRef idx="2">
-            <a:schemeClr val="accent1"/>
-          </a:effectRef>
-          <a:fontRef idx="minor">
-            <a:schemeClr val="lt1"/>
-          </a:fontRef>
-        </p:style>
-        <p:txBody>
-          <a:bodyPr rtlCol="0" anchor="ctr"/>
-          <a:lstStyle/>
-          <a:p>
-            <a:pPr algn="ctr"/>
-          </a:p>
-        </p:txBody>
-      </p:sp>
-      <p:sp>
-        <p:nvSpPr>
-          <p:cNvPr id="45" name="Rounded Rectangle 44"/>
-          <p:cNvSpPr/>
-          <p:nvPr/>
-        </p:nvSpPr>
-        <p:spPr>
-          <a:xfrm>
-            <a:off x="4297680" y="2980944"/>
-            <a:ext cx="7589520" cy="1719072"/>
-          </a:xfrm>
-          <a:prstGeom prst="roundRect">
-            <a:avLst>
-              <a:gd name="adj" fmla="val 5000"/>
-            </a:avLst>
-          </a:prstGeom>
-          <a:solidFill>
-            <a:srgbClr val="FFFCF8"/>
-          </a:solidFill>
-          <a:ln>
-            <a:noFill/>
-          </a:ln>
-        </p:spPr>
-        <p:style>
-          <a:lnRef idx="1">
-            <a:schemeClr val="accent1"/>
-          </a:lnRef>
-          <a:fillRef idx="3">
-            <a:schemeClr val="accent1"/>
-          </a:fillRef>
-          <a:effectRef idx="2">
-            <a:schemeClr val="accent1"/>
-          </a:effectRef>
-          <a:fontRef idx="minor">
-            <a:schemeClr val="lt1"/>
-          </a:fontRef>
-        </p:style>
-        <p:txBody>
-          <a:bodyPr rtlCol="0" anchor="ctr"/>
-          <a:lstStyle/>
-          <a:p>
-            <a:pPr algn="ctr"/>
-          </a:p>
-        </p:txBody>
-      </p:sp>
-      <p:sp>
-        <p:nvSpPr>
-          <p:cNvPr id="46" name="Rectangle 45"/>
-          <p:cNvSpPr/>
-          <p:nvPr/>
-        </p:nvSpPr>
-        <p:spPr>
-          <a:xfrm>
-            <a:off x="4480560" y="3136391"/>
-            <a:ext cx="68580" cy="201168"/>
-          </a:xfrm>
-          <a:prstGeom prst="rect">
-            <a:avLst/>
-          </a:prstGeom>
-          <a:solidFill>
-            <a:srgbClr val="8E1B2C"/>
-          </a:solidFill>
-          <a:ln>
-            <a:noFill/>
-          </a:ln>
-        </p:spPr>
-        <p:style>
-          <a:lnRef idx="1">
-            <a:schemeClr val="accent1"/>
-          </a:lnRef>
-          <a:fillRef idx="3">
-            <a:schemeClr val="accent1"/>
-          </a:fillRef>
-          <a:effectRef idx="2">
-            <a:schemeClr val="accent1"/>
-          </a:effectRef>
-          <a:fontRef idx="minor">
-            <a:schemeClr val="lt1"/>
-          </a:fontRef>
-        </p:style>
-        <p:txBody>
-          <a:bodyPr rtlCol="0" anchor="ctr"/>
-          <a:lstStyle/>
-          <a:p>
-            <a:pPr algn="ctr"/>
-          </a:p>
-        </p:txBody>
-      </p:sp>
-      <p:sp>
-        <p:nvSpPr>
-          <p:cNvPr id="47" name="TextBox 46"/>
-          <p:cNvSpPr txBox="1"/>
-          <p:nvPr/>
-        </p:nvSpPr>
-        <p:spPr>
-          <a:xfrm>
-            <a:off x="4608576" y="3090672"/>
-            <a:ext cx="7095744" cy="310896"/>
-          </a:xfrm>
-          <a:prstGeom prst="rect">
-            <a:avLst/>
-          </a:prstGeom>
-          <a:noFill/>
-        </p:spPr>
-        <p:txBody>
-          <a:bodyPr wrap="square" lIns="18288" rIns="18288" tIns="0" bIns="0"/>
-          <a:lstStyle/>
-          <a:p>
-            <a:pPr algn="l">
-              <a:spcBef>
-                <a:spcPts val="0"/>
-              </a:spcBef>
-              <a:spcAft>
-                <a:spcPts val="0"/>
-              </a:spcAft>
-            </a:pPr>
-            <a:r>
-              <a:rPr sz="1600" b="1" i="0" lang="zh-CN" altLang="en-US">
-                <a:solidFill>
-                  <a:srgbClr val="6E1422"/>
-                </a:solidFill>
-                <a:latin typeface="微软雅黑"/>
-                <a:ea typeface="微软雅黑"/>
-                <a:cs typeface="微软雅黑"/>
-              </a:rPr>
-              <a:t>三、入党动机</a:t>
-            </a:r>
-          </a:p>
-        </p:txBody>
-      </p:sp>
-      <p:sp>
-        <p:nvSpPr>
-          <p:cNvPr id="48" name="TextBox 47"/>
-          <p:cNvSpPr txBox="1"/>
-          <p:nvPr/>
-        </p:nvSpPr>
-        <p:spPr>
-          <a:xfrm>
-            <a:off x="4462272" y="3438144"/>
-            <a:ext cx="7269480" cy="1133856"/>
-          </a:xfrm>
-          <a:prstGeom prst="rect">
-            <a:avLst/>
-          </a:prstGeom>
-          <a:noFill/>
-        </p:spPr>
-        <p:txBody>
-          <a:bodyPr wrap="square" lIns="18288" rIns="18288" tIns="0" bIns="0"/>
-          <a:lstStyle/>
+              <a:t>我曾担任班级组织委员。任职期间，协助班级做好推优和入党积极分子的培养联系，</a:t>
+            </a:r>
+          </a:p>
           <a:p>
             <a:pPr algn="l">
               <a:lnSpc>
-                <a:spcPct val="112000"/>
+                <a:spcPct val="108000"/>
               </a:lnSpc>
               <a:spcBef>
                 <a:spcPts val="0"/>
@@ -5710,7 +5453,7 @@
                 <a:ea typeface="微软雅黑"/>
                 <a:cs typeface="微软雅黑"/>
               </a:rPr>
-              <a:t>我在学习和工作中，习惯把事情做扎实，也明白个人进步离不开集体。</a:t>
+              <a:t>了解同学思想状况，把组织交办的事项按时办完。</a:t>
             </a:r>
           </a:p>
           <a:p>
@@ -5734,9 +5477,205 @@
                 <a:ea typeface="微软雅黑"/>
                 <a:cs typeface="微软雅黑"/>
               </a:rPr>
-              <a:t>我申请入党，是希望按党员标准要求自己：读原著、学原文、悟原理，</a:t>
-            </a:r>
-          </a:p>
+              <a:t>这段经历让我熟悉发展党员的基本程序，也让我习惯按程序办事、对同学负责。</a:t>
+            </a:r>
+          </a:p>
+        </p:txBody>
+      </p:sp>
+      <p:sp>
+        <p:nvSpPr>
+          <p:cNvPr id="46" name="Rounded Rectangle 45"/>
+          <p:cNvSpPr/>
+          <p:nvPr/>
+        </p:nvSpPr>
+        <p:spPr>
+          <a:xfrm>
+            <a:off x="4325112" y="3012948"/>
+            <a:ext cx="7589520" cy="1719072"/>
+          </a:xfrm>
+          <a:prstGeom prst="roundRect">
+            <a:avLst>
+              <a:gd name="adj" fmla="val 5000"/>
+            </a:avLst>
+          </a:prstGeom>
+          <a:solidFill>
+            <a:srgbClr val="E3D9CE"/>
+          </a:solidFill>
+          <a:ln>
+            <a:noFill/>
+          </a:ln>
+        </p:spPr>
+        <p:style>
+          <a:lnRef idx="1">
+            <a:schemeClr val="accent1"/>
+          </a:lnRef>
+          <a:fillRef idx="3">
+            <a:schemeClr val="accent1"/>
+          </a:fillRef>
+          <a:effectRef idx="2">
+            <a:schemeClr val="accent1"/>
+          </a:effectRef>
+          <a:fontRef idx="minor">
+            <a:schemeClr val="lt1"/>
+          </a:fontRef>
+        </p:style>
+        <p:txBody>
+          <a:bodyPr rtlCol="0" anchor="ctr"/>
+          <a:lstStyle/>
+          <a:p>
+            <a:pPr algn="ctr"/>
+          </a:p>
+        </p:txBody>
+      </p:sp>
+      <p:sp>
+        <p:nvSpPr>
+          <p:cNvPr id="47" name="Rounded Rectangle 46"/>
+          <p:cNvSpPr/>
+          <p:nvPr/>
+        </p:nvSpPr>
+        <p:spPr>
+          <a:xfrm>
+            <a:off x="4297680" y="2980944"/>
+            <a:ext cx="7589520" cy="1719072"/>
+          </a:xfrm>
+          <a:prstGeom prst="roundRect">
+            <a:avLst>
+              <a:gd name="adj" fmla="val 5000"/>
+            </a:avLst>
+          </a:prstGeom>
+          <a:solidFill>
+            <a:srgbClr val="FFFCF8"/>
+          </a:solidFill>
+          <a:ln>
+            <a:noFill/>
+          </a:ln>
+        </p:spPr>
+        <p:style>
+          <a:lnRef idx="1">
+            <a:schemeClr val="accent1"/>
+          </a:lnRef>
+          <a:fillRef idx="3">
+            <a:schemeClr val="accent1"/>
+          </a:fillRef>
+          <a:effectRef idx="2">
+            <a:schemeClr val="accent1"/>
+          </a:effectRef>
+          <a:fontRef idx="minor">
+            <a:schemeClr val="lt1"/>
+          </a:fontRef>
+        </p:style>
+        <p:txBody>
+          <a:bodyPr rtlCol="0" anchor="ctr"/>
+          <a:lstStyle/>
+          <a:p>
+            <a:pPr algn="ctr"/>
+          </a:p>
+        </p:txBody>
+      </p:sp>
+      <p:sp>
+        <p:nvSpPr>
+          <p:cNvPr id="48" name="Rectangle 47"/>
+          <p:cNvSpPr/>
+          <p:nvPr/>
+        </p:nvSpPr>
+        <p:spPr>
+          <a:xfrm>
+            <a:off x="4480560" y="3136391"/>
+            <a:ext cx="68580" cy="201168"/>
+          </a:xfrm>
+          <a:prstGeom prst="rect">
+            <a:avLst/>
+          </a:prstGeom>
+          <a:solidFill>
+            <a:srgbClr val="8E1B2C"/>
+          </a:solidFill>
+          <a:ln>
+            <a:noFill/>
+          </a:ln>
+        </p:spPr>
+        <p:style>
+          <a:lnRef idx="1">
+            <a:schemeClr val="accent1"/>
+          </a:lnRef>
+          <a:fillRef idx="3">
+            <a:schemeClr val="accent1"/>
+          </a:fillRef>
+          <a:effectRef idx="2">
+            <a:schemeClr val="accent1"/>
+          </a:effectRef>
+          <a:fontRef idx="minor">
+            <a:schemeClr val="lt1"/>
+          </a:fontRef>
+        </p:style>
+        <p:txBody>
+          <a:bodyPr rtlCol="0" anchor="ctr"/>
+          <a:lstStyle/>
+          <a:p>
+            <a:pPr algn="ctr"/>
+          </a:p>
+        </p:txBody>
+      </p:sp>
+      <p:sp>
+        <p:nvSpPr>
+          <p:cNvPr id="49" name="TextBox 48"/>
+          <p:cNvSpPr txBox="1"/>
+          <p:nvPr/>
+        </p:nvSpPr>
+        <p:spPr>
+          <a:xfrm>
+            <a:off x="4608576" y="3090672"/>
+            <a:ext cx="7095744" cy="310896"/>
+          </a:xfrm>
+          <a:prstGeom prst="rect">
+            <a:avLst/>
+          </a:prstGeom>
+          <a:noFill/>
+        </p:spPr>
+        <p:txBody>
+          <a:bodyPr wrap="square" lIns="18288" rIns="18288" tIns="0" bIns="0"/>
+          <a:lstStyle/>
+          <a:p>
+            <a:pPr algn="l">
+              <a:spcBef>
+                <a:spcPts val="0"/>
+              </a:spcBef>
+              <a:spcAft>
+                <a:spcPts val="0"/>
+              </a:spcAft>
+            </a:pPr>
+            <a:r>
+              <a:rPr sz="1600" b="1" i="0" lang="zh-CN" altLang="en-US">
+                <a:solidFill>
+                  <a:srgbClr val="6E1422"/>
+                </a:solidFill>
+                <a:latin typeface="微软雅黑"/>
+                <a:ea typeface="微软雅黑"/>
+                <a:cs typeface="微软雅黑"/>
+              </a:rPr>
+              <a:t>三、为何竞选副书记</a:t>
+            </a:r>
+          </a:p>
+        </p:txBody>
+      </p:sp>
+      <p:sp>
+        <p:nvSpPr>
+          <p:cNvPr id="50" name="TextBox 49"/>
+          <p:cNvSpPr txBox="1"/>
+          <p:nvPr/>
+        </p:nvSpPr>
+        <p:spPr>
+          <a:xfrm>
+            <a:off x="4462272" y="3438144"/>
+            <a:ext cx="7269480" cy="1133856"/>
+          </a:xfrm>
+          <a:prstGeom prst="rect">
+            <a:avLst/>
+          </a:prstGeom>
+          <a:noFill/>
+        </p:spPr>
+        <p:txBody>
+          <a:bodyPr wrap="square" lIns="18288" rIns="18288" tIns="0" bIns="0"/>
+          <a:lstStyle/>
           <a:p>
             <a:pPr algn="l">
               <a:lnSpc>
@@ -5758,250 +5697,9 @@
                 <a:ea typeface="微软雅黑"/>
                 <a:cs typeface="微软雅黑"/>
               </a:rPr>
-              <a:t>在专业上练好本领，在集体中主动担当，自觉接受组织考察。</a:t>
-            </a:r>
-          </a:p>
-        </p:txBody>
-      </p:sp>
-      <p:sp>
-        <p:nvSpPr>
-          <p:cNvPr id="49" name="Rounded Rectangle 48"/>
-          <p:cNvSpPr/>
-          <p:nvPr/>
-        </p:nvSpPr>
-        <p:spPr>
-          <a:xfrm>
-            <a:off x="320040" y="4860036"/>
-            <a:ext cx="3749039" cy="1444752"/>
-          </a:xfrm>
-          <a:prstGeom prst="roundRect">
-            <a:avLst>
-              <a:gd name="adj" fmla="val 5000"/>
-            </a:avLst>
-          </a:prstGeom>
-          <a:solidFill>
-            <a:srgbClr val="E3D9CE"/>
-          </a:solidFill>
-          <a:ln>
-            <a:noFill/>
-          </a:ln>
-        </p:spPr>
-        <p:style>
-          <a:lnRef idx="1">
-            <a:schemeClr val="accent1"/>
-          </a:lnRef>
-          <a:fillRef idx="3">
-            <a:schemeClr val="accent1"/>
-          </a:fillRef>
-          <a:effectRef idx="2">
-            <a:schemeClr val="accent1"/>
-          </a:effectRef>
-          <a:fontRef idx="minor">
-            <a:schemeClr val="lt1"/>
-          </a:fontRef>
-        </p:style>
-        <p:txBody>
-          <a:bodyPr rtlCol="0" anchor="ctr"/>
-          <a:lstStyle/>
-          <a:p>
-            <a:pPr algn="ctr"/>
-          </a:p>
-        </p:txBody>
-      </p:sp>
-      <p:sp>
-        <p:nvSpPr>
-          <p:cNvPr id="50" name="Rounded Rectangle 49"/>
-          <p:cNvSpPr/>
-          <p:nvPr/>
-        </p:nvSpPr>
-        <p:spPr>
-          <a:xfrm>
-            <a:off x="292608" y="4828032"/>
-            <a:ext cx="3749039" cy="1444752"/>
-          </a:xfrm>
-          <a:prstGeom prst="roundRect">
-            <a:avLst>
-              <a:gd name="adj" fmla="val 5000"/>
-            </a:avLst>
-          </a:prstGeom>
-          <a:solidFill>
-            <a:srgbClr val="FFFCF8"/>
-          </a:solidFill>
-          <a:ln>
-            <a:noFill/>
-          </a:ln>
-        </p:spPr>
-        <p:style>
-          <a:lnRef idx="1">
-            <a:schemeClr val="accent1"/>
-          </a:lnRef>
-          <a:fillRef idx="3">
-            <a:schemeClr val="accent1"/>
-          </a:fillRef>
-          <a:effectRef idx="2">
-            <a:schemeClr val="accent1"/>
-          </a:effectRef>
-          <a:fontRef idx="minor">
-            <a:schemeClr val="lt1"/>
-          </a:fontRef>
-        </p:style>
-        <p:txBody>
-          <a:bodyPr rtlCol="0" anchor="ctr"/>
-          <a:lstStyle/>
-          <a:p>
-            <a:pPr algn="ctr"/>
-          </a:p>
-        </p:txBody>
-      </p:sp>
-      <p:sp>
-        <p:nvSpPr>
-          <p:cNvPr id="51" name="Rounded Rectangle 50"/>
-          <p:cNvSpPr/>
-          <p:nvPr/>
-        </p:nvSpPr>
-        <p:spPr>
-          <a:xfrm>
-            <a:off x="292608" y="4828032"/>
-            <a:ext cx="3749039" cy="73152"/>
-          </a:xfrm>
-          <a:prstGeom prst="roundRect">
-            <a:avLst>
-              <a:gd name="adj" fmla="val 40000"/>
-            </a:avLst>
-          </a:prstGeom>
-          <a:solidFill>
-            <a:srgbClr val="8E1B2C"/>
-          </a:solidFill>
-          <a:ln>
-            <a:noFill/>
-          </a:ln>
-        </p:spPr>
-        <p:style>
-          <a:lnRef idx="1">
-            <a:schemeClr val="accent1"/>
-          </a:lnRef>
-          <a:fillRef idx="3">
-            <a:schemeClr val="accent1"/>
-          </a:fillRef>
-          <a:effectRef idx="2">
-            <a:schemeClr val="accent1"/>
-          </a:effectRef>
-          <a:fontRef idx="minor">
-            <a:schemeClr val="lt1"/>
-          </a:fontRef>
-        </p:style>
-        <p:txBody>
-          <a:bodyPr rtlCol="0" anchor="ctr"/>
-          <a:lstStyle/>
-          <a:p>
-            <a:pPr algn="ctr"/>
-          </a:p>
-        </p:txBody>
-      </p:sp>
-      <p:sp>
-        <p:nvSpPr>
-          <p:cNvPr id="52" name="Rectangle 51"/>
-          <p:cNvSpPr/>
-          <p:nvPr/>
-        </p:nvSpPr>
-        <p:spPr>
-          <a:xfrm>
-            <a:off x="292608" y="4873752"/>
-            <a:ext cx="3749039" cy="54864"/>
-          </a:xfrm>
-          <a:prstGeom prst="rect">
-            <a:avLst/>
-          </a:prstGeom>
-          <a:solidFill>
-            <a:srgbClr val="8E1B2C"/>
-          </a:solidFill>
-          <a:ln>
-            <a:noFill/>
-          </a:ln>
-        </p:spPr>
-        <p:style>
-          <a:lnRef idx="1">
-            <a:schemeClr val="accent1"/>
-          </a:lnRef>
-          <a:fillRef idx="3">
-            <a:schemeClr val="accent1"/>
-          </a:fillRef>
-          <a:effectRef idx="2">
-            <a:schemeClr val="accent1"/>
-          </a:effectRef>
-          <a:fontRef idx="minor">
-            <a:schemeClr val="lt1"/>
-          </a:fontRef>
-        </p:style>
-        <p:txBody>
-          <a:bodyPr rtlCol="0" anchor="ctr"/>
-          <a:lstStyle/>
-          <a:p>
-            <a:pPr algn="ctr"/>
-          </a:p>
-        </p:txBody>
-      </p:sp>
-      <p:sp>
-        <p:nvSpPr>
-          <p:cNvPr id="53" name="TextBox 52"/>
-          <p:cNvSpPr txBox="1"/>
-          <p:nvPr/>
-        </p:nvSpPr>
-        <p:spPr>
-          <a:xfrm>
-            <a:off x="438912" y="5029200"/>
-            <a:ext cx="3456432" cy="329184"/>
-          </a:xfrm>
-          <a:prstGeom prst="rect">
-            <a:avLst/>
-          </a:prstGeom>
-          <a:noFill/>
-        </p:spPr>
-        <p:txBody>
-          <a:bodyPr wrap="square" lIns="18288" rIns="18288" tIns="0" bIns="0"/>
-          <a:lstStyle/>
-          <a:p>
-            <a:pPr algn="l">
-              <a:spcBef>
-                <a:spcPts val="0"/>
-              </a:spcBef>
-              <a:spcAft>
-                <a:spcPts val="0"/>
-              </a:spcAft>
-            </a:pPr>
-            <a:r>
-              <a:rPr sz="1600" b="1" i="0" lang="zh-CN" altLang="en-US">
-                <a:solidFill>
-                  <a:srgbClr val="6E1422"/>
-                </a:solidFill>
-                <a:latin typeface="微软雅黑"/>
-                <a:ea typeface="微软雅黑"/>
-                <a:cs typeface="微软雅黑"/>
-              </a:rPr>
-              <a:t>四、优点</a:t>
-            </a:r>
-          </a:p>
-        </p:txBody>
-      </p:sp>
-      <p:sp>
-        <p:nvSpPr>
-          <p:cNvPr id="54" name="TextBox 53"/>
-          <p:cNvSpPr txBox="1"/>
-          <p:nvPr/>
-        </p:nvSpPr>
-        <p:spPr>
-          <a:xfrm>
-            <a:off x="457200" y="5303520"/>
-            <a:ext cx="3419856" cy="841248"/>
-          </a:xfrm>
-          <a:prstGeom prst="rect">
-            <a:avLst/>
-          </a:prstGeom>
-          <a:noFill/>
-        </p:spPr>
-        <p:txBody>
-          <a:bodyPr wrap="square" lIns="18288" rIns="18288" tIns="0" bIns="0"/>
-          <a:lstStyle/>
+              <a:t>我已加入中国共产党。竞选党支部副书记，是希望在书记带领下，</a:t>
+            </a:r>
+          </a:p>
           <a:p>
             <a:pPr algn="l">
               <a:lnSpc>
@@ -6023,7 +5721,7 @@
                 <a:ea typeface="微软雅黑"/>
                 <a:cs typeface="微软雅黑"/>
               </a:rPr>
-              <a:t>能沉下心，把一件事做完。</a:t>
+              <a:t>把班级组织委员的经验用到支部。</a:t>
             </a:r>
           </a:p>
           <a:p>
@@ -6047,250 +5745,9 @@
                 <a:ea typeface="微软雅黑"/>
                 <a:cs typeface="微软雅黑"/>
               </a:rPr>
-              <a:t>和身边的人合作时，愿意负责到底。</a:t>
-            </a:r>
-          </a:p>
-        </p:txBody>
-      </p:sp>
-      <p:sp>
-        <p:nvSpPr>
-          <p:cNvPr id="55" name="Rounded Rectangle 54"/>
-          <p:cNvSpPr/>
-          <p:nvPr/>
-        </p:nvSpPr>
-        <p:spPr>
-          <a:xfrm>
-            <a:off x="4201668" y="4860036"/>
-            <a:ext cx="3749039" cy="1444752"/>
-          </a:xfrm>
-          <a:prstGeom prst="roundRect">
-            <a:avLst>
-              <a:gd name="adj" fmla="val 5000"/>
-            </a:avLst>
-          </a:prstGeom>
-          <a:solidFill>
-            <a:srgbClr val="E3D9CE"/>
-          </a:solidFill>
-          <a:ln>
-            <a:noFill/>
-          </a:ln>
-        </p:spPr>
-        <p:style>
-          <a:lnRef idx="1">
-            <a:schemeClr val="accent1"/>
-          </a:lnRef>
-          <a:fillRef idx="3">
-            <a:schemeClr val="accent1"/>
-          </a:fillRef>
-          <a:effectRef idx="2">
-            <a:schemeClr val="accent1"/>
-          </a:effectRef>
-          <a:fontRef idx="minor">
-            <a:schemeClr val="lt1"/>
-          </a:fontRef>
-        </p:style>
-        <p:txBody>
-          <a:bodyPr rtlCol="0" anchor="ctr"/>
-          <a:lstStyle/>
-          <a:p>
-            <a:pPr algn="ctr"/>
-          </a:p>
-        </p:txBody>
-      </p:sp>
-      <p:sp>
-        <p:nvSpPr>
-          <p:cNvPr id="56" name="Rounded Rectangle 55"/>
-          <p:cNvSpPr/>
-          <p:nvPr/>
-        </p:nvSpPr>
-        <p:spPr>
-          <a:xfrm>
-            <a:off x="4174235" y="4828032"/>
-            <a:ext cx="3749039" cy="1444752"/>
-          </a:xfrm>
-          <a:prstGeom prst="roundRect">
-            <a:avLst>
-              <a:gd name="adj" fmla="val 5000"/>
-            </a:avLst>
-          </a:prstGeom>
-          <a:solidFill>
-            <a:srgbClr val="FFFCF8"/>
-          </a:solidFill>
-          <a:ln>
-            <a:noFill/>
-          </a:ln>
-        </p:spPr>
-        <p:style>
-          <a:lnRef idx="1">
-            <a:schemeClr val="accent1"/>
-          </a:lnRef>
-          <a:fillRef idx="3">
-            <a:schemeClr val="accent1"/>
-          </a:fillRef>
-          <a:effectRef idx="2">
-            <a:schemeClr val="accent1"/>
-          </a:effectRef>
-          <a:fontRef idx="minor">
-            <a:schemeClr val="lt1"/>
-          </a:fontRef>
-        </p:style>
-        <p:txBody>
-          <a:bodyPr rtlCol="0" anchor="ctr"/>
-          <a:lstStyle/>
-          <a:p>
-            <a:pPr algn="ctr"/>
-          </a:p>
-        </p:txBody>
-      </p:sp>
-      <p:sp>
-        <p:nvSpPr>
-          <p:cNvPr id="57" name="Rounded Rectangle 56"/>
-          <p:cNvSpPr/>
-          <p:nvPr/>
-        </p:nvSpPr>
-        <p:spPr>
-          <a:xfrm>
-            <a:off x="4174235" y="4828032"/>
-            <a:ext cx="3749039" cy="73152"/>
-          </a:xfrm>
-          <a:prstGeom prst="roundRect">
-            <a:avLst>
-              <a:gd name="adj" fmla="val 40000"/>
-            </a:avLst>
-          </a:prstGeom>
-          <a:solidFill>
-            <a:srgbClr val="8E1B2C"/>
-          </a:solidFill>
-          <a:ln>
-            <a:noFill/>
-          </a:ln>
-        </p:spPr>
-        <p:style>
-          <a:lnRef idx="1">
-            <a:schemeClr val="accent1"/>
-          </a:lnRef>
-          <a:fillRef idx="3">
-            <a:schemeClr val="accent1"/>
-          </a:fillRef>
-          <a:effectRef idx="2">
-            <a:schemeClr val="accent1"/>
-          </a:effectRef>
-          <a:fontRef idx="minor">
-            <a:schemeClr val="lt1"/>
-          </a:fontRef>
-        </p:style>
-        <p:txBody>
-          <a:bodyPr rtlCol="0" anchor="ctr"/>
-          <a:lstStyle/>
-          <a:p>
-            <a:pPr algn="ctr"/>
-          </a:p>
-        </p:txBody>
-      </p:sp>
-      <p:sp>
-        <p:nvSpPr>
-          <p:cNvPr id="58" name="Rectangle 57"/>
-          <p:cNvSpPr/>
-          <p:nvPr/>
-        </p:nvSpPr>
-        <p:spPr>
-          <a:xfrm>
-            <a:off x="4174235" y="4873752"/>
-            <a:ext cx="3749039" cy="54864"/>
-          </a:xfrm>
-          <a:prstGeom prst="rect">
-            <a:avLst/>
-          </a:prstGeom>
-          <a:solidFill>
-            <a:srgbClr val="8E1B2C"/>
-          </a:solidFill>
-          <a:ln>
-            <a:noFill/>
-          </a:ln>
-        </p:spPr>
-        <p:style>
-          <a:lnRef idx="1">
-            <a:schemeClr val="accent1"/>
-          </a:lnRef>
-          <a:fillRef idx="3">
-            <a:schemeClr val="accent1"/>
-          </a:fillRef>
-          <a:effectRef idx="2">
-            <a:schemeClr val="accent1"/>
-          </a:effectRef>
-          <a:fontRef idx="minor">
-            <a:schemeClr val="lt1"/>
-          </a:fontRef>
-        </p:style>
-        <p:txBody>
-          <a:bodyPr rtlCol="0" anchor="ctr"/>
-          <a:lstStyle/>
-          <a:p>
-            <a:pPr algn="ctr"/>
-          </a:p>
-        </p:txBody>
-      </p:sp>
-      <p:sp>
-        <p:nvSpPr>
-          <p:cNvPr id="59" name="TextBox 58"/>
-          <p:cNvSpPr txBox="1"/>
-          <p:nvPr/>
-        </p:nvSpPr>
-        <p:spPr>
-          <a:xfrm>
-            <a:off x="4320540" y="5029200"/>
-            <a:ext cx="3456432" cy="329184"/>
-          </a:xfrm>
-          <a:prstGeom prst="rect">
-            <a:avLst/>
-          </a:prstGeom>
-          <a:noFill/>
-        </p:spPr>
-        <p:txBody>
-          <a:bodyPr wrap="square" lIns="18288" rIns="18288" tIns="0" bIns="0"/>
-          <a:lstStyle/>
-          <a:p>
-            <a:pPr algn="l">
-              <a:spcBef>
-                <a:spcPts val="0"/>
-              </a:spcBef>
-              <a:spcAft>
-                <a:spcPts val="0"/>
-              </a:spcAft>
-            </a:pPr>
-            <a:r>
-              <a:rPr sz="1600" b="1" i="0" lang="zh-CN" altLang="en-US">
-                <a:solidFill>
-                  <a:srgbClr val="6E1422"/>
-                </a:solidFill>
-                <a:latin typeface="微软雅黑"/>
-                <a:ea typeface="微软雅黑"/>
-                <a:cs typeface="微软雅黑"/>
-              </a:rPr>
-              <a:t>不足</a:t>
-            </a:r>
-          </a:p>
-        </p:txBody>
-      </p:sp>
-      <p:sp>
-        <p:nvSpPr>
-          <p:cNvPr id="60" name="TextBox 59"/>
-          <p:cNvSpPr txBox="1"/>
-          <p:nvPr/>
-        </p:nvSpPr>
-        <p:spPr>
-          <a:xfrm>
-            <a:off x="4338827" y="5303520"/>
-            <a:ext cx="3419856" cy="841248"/>
-          </a:xfrm>
-          <a:prstGeom prst="rect">
-            <a:avLst/>
-          </a:prstGeom>
-          <a:noFill/>
-        </p:spPr>
-        <p:txBody>
-          <a:bodyPr wrap="square" lIns="18288" rIns="18288" tIns="0" bIns="0"/>
-          <a:lstStyle/>
+              <a:t>如果当选，我会协助做好党员发展、教育和管理，把组织生活落到实处，</a:t>
+            </a:r>
+          </a:p>
           <a:p>
             <a:pPr algn="l">
               <a:lnSpc>
@@ -6312,7 +5769,272 @@
                 <a:ea typeface="微软雅黑"/>
                 <a:cs typeface="微软雅黑"/>
               </a:rPr>
-              <a:t>有时陷在细节里，主动沟通不够。</a:t>
+              <a:t>及时把同学的情况向支部反映。</a:t>
+            </a:r>
+          </a:p>
+        </p:txBody>
+      </p:sp>
+      <p:sp>
+        <p:nvSpPr>
+          <p:cNvPr id="51" name="Rounded Rectangle 50"/>
+          <p:cNvSpPr/>
+          <p:nvPr/>
+        </p:nvSpPr>
+        <p:spPr>
+          <a:xfrm>
+            <a:off x="320040" y="4860036"/>
+            <a:ext cx="3749039" cy="1444752"/>
+          </a:xfrm>
+          <a:prstGeom prst="roundRect">
+            <a:avLst>
+              <a:gd name="adj" fmla="val 5000"/>
+            </a:avLst>
+          </a:prstGeom>
+          <a:solidFill>
+            <a:srgbClr val="E3D9CE"/>
+          </a:solidFill>
+          <a:ln>
+            <a:noFill/>
+          </a:ln>
+        </p:spPr>
+        <p:style>
+          <a:lnRef idx="1">
+            <a:schemeClr val="accent1"/>
+          </a:lnRef>
+          <a:fillRef idx="3">
+            <a:schemeClr val="accent1"/>
+          </a:fillRef>
+          <a:effectRef idx="2">
+            <a:schemeClr val="accent1"/>
+          </a:effectRef>
+          <a:fontRef idx="minor">
+            <a:schemeClr val="lt1"/>
+          </a:fontRef>
+        </p:style>
+        <p:txBody>
+          <a:bodyPr rtlCol="0" anchor="ctr"/>
+          <a:lstStyle/>
+          <a:p>
+            <a:pPr algn="ctr"/>
+          </a:p>
+        </p:txBody>
+      </p:sp>
+      <p:sp>
+        <p:nvSpPr>
+          <p:cNvPr id="52" name="Rounded Rectangle 51"/>
+          <p:cNvSpPr/>
+          <p:nvPr/>
+        </p:nvSpPr>
+        <p:spPr>
+          <a:xfrm>
+            <a:off x="292608" y="4828032"/>
+            <a:ext cx="3749039" cy="1444752"/>
+          </a:xfrm>
+          <a:prstGeom prst="roundRect">
+            <a:avLst>
+              <a:gd name="adj" fmla="val 5000"/>
+            </a:avLst>
+          </a:prstGeom>
+          <a:solidFill>
+            <a:srgbClr val="FFFCF8"/>
+          </a:solidFill>
+          <a:ln>
+            <a:noFill/>
+          </a:ln>
+        </p:spPr>
+        <p:style>
+          <a:lnRef idx="1">
+            <a:schemeClr val="accent1"/>
+          </a:lnRef>
+          <a:fillRef idx="3">
+            <a:schemeClr val="accent1"/>
+          </a:fillRef>
+          <a:effectRef idx="2">
+            <a:schemeClr val="accent1"/>
+          </a:effectRef>
+          <a:fontRef idx="minor">
+            <a:schemeClr val="lt1"/>
+          </a:fontRef>
+        </p:style>
+        <p:txBody>
+          <a:bodyPr rtlCol="0" anchor="ctr"/>
+          <a:lstStyle/>
+          <a:p>
+            <a:pPr algn="ctr"/>
+          </a:p>
+        </p:txBody>
+      </p:sp>
+      <p:sp>
+        <p:nvSpPr>
+          <p:cNvPr id="53" name="Rounded Rectangle 52"/>
+          <p:cNvSpPr/>
+          <p:nvPr/>
+        </p:nvSpPr>
+        <p:spPr>
+          <a:xfrm>
+            <a:off x="292608" y="4828032"/>
+            <a:ext cx="3749039" cy="73152"/>
+          </a:xfrm>
+          <a:prstGeom prst="roundRect">
+            <a:avLst>
+              <a:gd name="adj" fmla="val 40000"/>
+            </a:avLst>
+          </a:prstGeom>
+          <a:solidFill>
+            <a:srgbClr val="8E1B2C"/>
+          </a:solidFill>
+          <a:ln>
+            <a:noFill/>
+          </a:ln>
+        </p:spPr>
+        <p:style>
+          <a:lnRef idx="1">
+            <a:schemeClr val="accent1"/>
+          </a:lnRef>
+          <a:fillRef idx="3">
+            <a:schemeClr val="accent1"/>
+          </a:fillRef>
+          <a:effectRef idx="2">
+            <a:schemeClr val="accent1"/>
+          </a:effectRef>
+          <a:fontRef idx="minor">
+            <a:schemeClr val="lt1"/>
+          </a:fontRef>
+        </p:style>
+        <p:txBody>
+          <a:bodyPr rtlCol="0" anchor="ctr"/>
+          <a:lstStyle/>
+          <a:p>
+            <a:pPr algn="ctr"/>
+          </a:p>
+        </p:txBody>
+      </p:sp>
+      <p:sp>
+        <p:nvSpPr>
+          <p:cNvPr id="54" name="Rectangle 53"/>
+          <p:cNvSpPr/>
+          <p:nvPr/>
+        </p:nvSpPr>
+        <p:spPr>
+          <a:xfrm>
+            <a:off x="292608" y="4873752"/>
+            <a:ext cx="3749039" cy="54864"/>
+          </a:xfrm>
+          <a:prstGeom prst="rect">
+            <a:avLst/>
+          </a:prstGeom>
+          <a:solidFill>
+            <a:srgbClr val="8E1B2C"/>
+          </a:solidFill>
+          <a:ln>
+            <a:noFill/>
+          </a:ln>
+        </p:spPr>
+        <p:style>
+          <a:lnRef idx="1">
+            <a:schemeClr val="accent1"/>
+          </a:lnRef>
+          <a:fillRef idx="3">
+            <a:schemeClr val="accent1"/>
+          </a:fillRef>
+          <a:effectRef idx="2">
+            <a:schemeClr val="accent1"/>
+          </a:effectRef>
+          <a:fontRef idx="minor">
+            <a:schemeClr val="lt1"/>
+          </a:fontRef>
+        </p:style>
+        <p:txBody>
+          <a:bodyPr rtlCol="0" anchor="ctr"/>
+          <a:lstStyle/>
+          <a:p>
+            <a:pPr algn="ctr"/>
+          </a:p>
+        </p:txBody>
+      </p:sp>
+      <p:sp>
+        <p:nvSpPr>
+          <p:cNvPr id="55" name="TextBox 54"/>
+          <p:cNvSpPr txBox="1"/>
+          <p:nvPr/>
+        </p:nvSpPr>
+        <p:spPr>
+          <a:xfrm>
+            <a:off x="438912" y="5029200"/>
+            <a:ext cx="3456432" cy="329184"/>
+          </a:xfrm>
+          <a:prstGeom prst="rect">
+            <a:avLst/>
+          </a:prstGeom>
+          <a:noFill/>
+        </p:spPr>
+        <p:txBody>
+          <a:bodyPr wrap="square" lIns="18288" rIns="18288" tIns="0" bIns="0"/>
+          <a:lstStyle/>
+          <a:p>
+            <a:pPr algn="l">
+              <a:spcBef>
+                <a:spcPts val="0"/>
+              </a:spcBef>
+              <a:spcAft>
+                <a:spcPts val="0"/>
+              </a:spcAft>
+            </a:pPr>
+            <a:r>
+              <a:rPr sz="1600" b="1" i="0" lang="zh-CN" altLang="en-US">
+                <a:solidFill>
+                  <a:srgbClr val="6E1422"/>
+                </a:solidFill>
+                <a:latin typeface="微软雅黑"/>
+                <a:ea typeface="微软雅黑"/>
+                <a:cs typeface="微软雅黑"/>
+              </a:rPr>
+              <a:t>四、组织委员给我的</a:t>
+            </a:r>
+          </a:p>
+        </p:txBody>
+      </p:sp>
+      <p:sp>
+        <p:nvSpPr>
+          <p:cNvPr id="56" name="TextBox 55"/>
+          <p:cNvSpPr txBox="1"/>
+          <p:nvPr/>
+        </p:nvSpPr>
+        <p:spPr>
+          <a:xfrm>
+            <a:off x="457200" y="5303520"/>
+            <a:ext cx="3419856" cy="841248"/>
+          </a:xfrm>
+          <a:prstGeom prst="rect">
+            <a:avLst/>
+          </a:prstGeom>
+          <a:noFill/>
+        </p:spPr>
+        <p:txBody>
+          <a:bodyPr wrap="square" lIns="18288" rIns="18288" tIns="0" bIns="0"/>
+          <a:lstStyle/>
+          <a:p>
+            <a:pPr algn="l">
+              <a:lnSpc>
+                <a:spcPct val="108000"/>
+              </a:lnSpc>
+              <a:spcBef>
+                <a:spcPts val="0"/>
+              </a:spcBef>
+              <a:spcAft>
+                <a:spcPts val="0"/>
+              </a:spcAft>
+            </a:pPr>
+            <a:r>
+              <a:rPr sz="1500" b="0" i="0" lang="zh-CN" altLang="en-US">
+                <a:solidFill>
+                  <a:srgbClr val="2C2622"/>
+                </a:solidFill>
+                <a:latin typeface="微软雅黑"/>
+                <a:ea typeface="微软雅黑"/>
+                <a:cs typeface="微软雅黑"/>
+              </a:rPr>
+              <a:t>熟悉推优和发展党员的程序。</a:t>
             </a:r>
           </a:p>
           <a:p>
@@ -6336,20 +6058,20 @@
                 <a:ea typeface="微软雅黑"/>
                 <a:cs typeface="微软雅黑"/>
               </a:rPr>
-              <a:t>党的理论学习还不够系统。</a:t>
-            </a:r>
-          </a:p>
-        </p:txBody>
-      </p:sp>
-      <p:sp>
-        <p:nvSpPr>
-          <p:cNvPr id="61" name="Rounded Rectangle 60"/>
+              <a:t>交办的事愿意跟到办完。</a:t>
+            </a:r>
+          </a:p>
+        </p:txBody>
+      </p:sp>
+      <p:sp>
+        <p:nvSpPr>
+          <p:cNvPr id="57" name="Rounded Rectangle 56"/>
           <p:cNvSpPr/>
           <p:nvPr/>
         </p:nvSpPr>
         <p:spPr>
           <a:xfrm>
-            <a:off x="8083295" y="4860036"/>
+            <a:off x="4201668" y="4860036"/>
             <a:ext cx="3749039" cy="1444752"/>
           </a:xfrm>
           <a:prstGeom prst="roundRect">
@@ -6388,13 +6110,13 @@
       </p:sp>
       <p:sp>
         <p:nvSpPr>
-          <p:cNvPr id="62" name="Rounded Rectangle 61"/>
+          <p:cNvPr id="58" name="Rounded Rectangle 57"/>
           <p:cNvSpPr/>
           <p:nvPr/>
         </p:nvSpPr>
         <p:spPr>
           <a:xfrm>
-            <a:off x="8055863" y="4828032"/>
+            <a:off x="4174235" y="4828032"/>
             <a:ext cx="3749039" cy="1444752"/>
           </a:xfrm>
           <a:prstGeom prst="roundRect">
@@ -6433,13 +6155,13 @@
       </p:sp>
       <p:sp>
         <p:nvSpPr>
-          <p:cNvPr id="63" name="Rounded Rectangle 62"/>
+          <p:cNvPr id="59" name="Rounded Rectangle 58"/>
           <p:cNvSpPr/>
           <p:nvPr/>
         </p:nvSpPr>
         <p:spPr>
           <a:xfrm>
-            <a:off x="8055863" y="4828032"/>
+            <a:off x="4174235" y="4828032"/>
             <a:ext cx="3749039" cy="73152"/>
           </a:xfrm>
           <a:prstGeom prst="roundRect">
@@ -6478,13 +6200,13 @@
       </p:sp>
       <p:sp>
         <p:nvSpPr>
-          <p:cNvPr id="64" name="Rectangle 63"/>
+          <p:cNvPr id="60" name="Rectangle 59"/>
           <p:cNvSpPr/>
           <p:nvPr/>
         </p:nvSpPr>
         <p:spPr>
           <a:xfrm>
-            <a:off x="8055863" y="4873752"/>
+            <a:off x="4174235" y="4873752"/>
             <a:ext cx="3749039" cy="54864"/>
           </a:xfrm>
           <a:prstGeom prst="rect">
@@ -6521,13 +6243,13 @@
       </p:sp>
       <p:sp>
         <p:nvSpPr>
-          <p:cNvPr id="65" name="TextBox 64"/>
+          <p:cNvPr id="61" name="TextBox 60"/>
           <p:cNvSpPr txBox="1"/>
           <p:nvPr/>
         </p:nvSpPr>
         <p:spPr>
           <a:xfrm>
-            <a:off x="8202167" y="5029200"/>
+            <a:off x="4320540" y="5029200"/>
             <a:ext cx="3456432" cy="329184"/>
           </a:xfrm>
           <a:prstGeom prst="rect">
@@ -6556,20 +6278,20 @@
                 <a:ea typeface="微软雅黑"/>
                 <a:cs typeface="微软雅黑"/>
               </a:rPr>
-              <a:t>打算</a:t>
-            </a:r>
-          </a:p>
-        </p:txBody>
-      </p:sp>
-      <p:sp>
-        <p:nvSpPr>
-          <p:cNvPr id="66" name="TextBox 65"/>
+              <a:t>还需要补的</a:t>
+            </a:r>
+          </a:p>
+        </p:txBody>
+      </p:sp>
+      <p:sp>
+        <p:nvSpPr>
+          <p:cNvPr id="62" name="TextBox 61"/>
           <p:cNvSpPr txBox="1"/>
           <p:nvPr/>
         </p:nvSpPr>
         <p:spPr>
           <a:xfrm>
-            <a:off x="8220455" y="5303520"/>
+            <a:off x="4338827" y="5303520"/>
             <a:ext cx="3419856" cy="841248"/>
           </a:xfrm>
           <a:prstGeom prst="rect">
@@ -6601,7 +6323,7 @@
                 <a:ea typeface="微软雅黑"/>
                 <a:cs typeface="微软雅黑"/>
               </a:rPr>
-              <a:t>读原著、学原文、悟原理。</a:t>
+              <a:t>主动沟通还不够，理论学习要更系统。</a:t>
             </a:r>
           </a:p>
           <a:p>
@@ -6625,24 +6347,116 @@
                 <a:ea typeface="微软雅黑"/>
                 <a:cs typeface="微软雅黑"/>
               </a:rPr>
-              <a:t>专业上练好本领，在集体中多担当。</a:t>
-            </a:r>
-          </a:p>
-        </p:txBody>
-      </p:sp>
-      <p:sp>
-        <p:nvSpPr>
-          <p:cNvPr id="67" name="Rectangle 66"/>
+              <a:t>支部工作不能只靠班级经验。</a:t>
+            </a:r>
+          </a:p>
+        </p:txBody>
+      </p:sp>
+      <p:sp>
+        <p:nvSpPr>
+          <p:cNvPr id="63" name="Rounded Rectangle 62"/>
           <p:cNvSpPr/>
           <p:nvPr/>
         </p:nvSpPr>
         <p:spPr>
           <a:xfrm>
-            <a:off x="0" y="6473952"/>
-            <a:ext cx="12191695" cy="384048"/>
-          </a:xfrm>
-          <a:prstGeom prst="rect">
-            <a:avLst/>
+            <a:off x="8083295" y="4860036"/>
+            <a:ext cx="3749039" cy="1444752"/>
+          </a:xfrm>
+          <a:prstGeom prst="roundRect">
+            <a:avLst>
+              <a:gd name="adj" fmla="val 5000"/>
+            </a:avLst>
+          </a:prstGeom>
+          <a:solidFill>
+            <a:srgbClr val="E3D9CE"/>
+          </a:solidFill>
+          <a:ln>
+            <a:noFill/>
+          </a:ln>
+        </p:spPr>
+        <p:style>
+          <a:lnRef idx="1">
+            <a:schemeClr val="accent1"/>
+          </a:lnRef>
+          <a:fillRef idx="3">
+            <a:schemeClr val="accent1"/>
+          </a:fillRef>
+          <a:effectRef idx="2">
+            <a:schemeClr val="accent1"/>
+          </a:effectRef>
+          <a:fontRef idx="minor">
+            <a:schemeClr val="lt1"/>
+          </a:fontRef>
+        </p:style>
+        <p:txBody>
+          <a:bodyPr rtlCol="0" anchor="ctr"/>
+          <a:lstStyle/>
+          <a:p>
+            <a:pPr algn="ctr"/>
+          </a:p>
+        </p:txBody>
+      </p:sp>
+      <p:sp>
+        <p:nvSpPr>
+          <p:cNvPr id="64" name="Rounded Rectangle 63"/>
+          <p:cNvSpPr/>
+          <p:nvPr/>
+        </p:nvSpPr>
+        <p:spPr>
+          <a:xfrm>
+            <a:off x="8055863" y="4828032"/>
+            <a:ext cx="3749039" cy="1444752"/>
+          </a:xfrm>
+          <a:prstGeom prst="roundRect">
+            <a:avLst>
+              <a:gd name="adj" fmla="val 5000"/>
+            </a:avLst>
+          </a:prstGeom>
+          <a:solidFill>
+            <a:srgbClr val="FFFCF8"/>
+          </a:solidFill>
+          <a:ln>
+            <a:noFill/>
+          </a:ln>
+        </p:spPr>
+        <p:style>
+          <a:lnRef idx="1">
+            <a:schemeClr val="accent1"/>
+          </a:lnRef>
+          <a:fillRef idx="3">
+            <a:schemeClr val="accent1"/>
+          </a:fillRef>
+          <a:effectRef idx="2">
+            <a:schemeClr val="accent1"/>
+          </a:effectRef>
+          <a:fontRef idx="minor">
+            <a:schemeClr val="lt1"/>
+          </a:fontRef>
+        </p:style>
+        <p:txBody>
+          <a:bodyPr rtlCol="0" anchor="ctr"/>
+          <a:lstStyle/>
+          <a:p>
+            <a:pPr algn="ctr"/>
+          </a:p>
+        </p:txBody>
+      </p:sp>
+      <p:sp>
+        <p:nvSpPr>
+          <p:cNvPr id="65" name="Rounded Rectangle 64"/>
+          <p:cNvSpPr/>
+          <p:nvPr/>
+        </p:nvSpPr>
+        <p:spPr>
+          <a:xfrm>
+            <a:off x="8055863" y="4828032"/>
+            <a:ext cx="3749039" cy="73152"/>
+          </a:xfrm>
+          <a:prstGeom prst="roundRect">
+            <a:avLst>
+              <a:gd name="adj" fmla="val 40000"/>
+            </a:avLst>
           </a:prstGeom>
           <a:solidFill>
             <a:srgbClr val="8E1B2C"/>
@@ -6675,7 +6489,204 @@
       </p:sp>
       <p:sp>
         <p:nvSpPr>
-          <p:cNvPr id="68" name="Rectangle 67"/>
+          <p:cNvPr id="66" name="Rectangle 65"/>
+          <p:cNvSpPr/>
+          <p:nvPr/>
+        </p:nvSpPr>
+        <p:spPr>
+          <a:xfrm>
+            <a:off x="8055863" y="4873752"/>
+            <a:ext cx="3749039" cy="54864"/>
+          </a:xfrm>
+          <a:prstGeom prst="rect">
+            <a:avLst/>
+          </a:prstGeom>
+          <a:solidFill>
+            <a:srgbClr val="8E1B2C"/>
+          </a:solidFill>
+          <a:ln>
+            <a:noFill/>
+          </a:ln>
+        </p:spPr>
+        <p:style>
+          <a:lnRef idx="1">
+            <a:schemeClr val="accent1"/>
+          </a:lnRef>
+          <a:fillRef idx="3">
+            <a:schemeClr val="accent1"/>
+          </a:fillRef>
+          <a:effectRef idx="2">
+            <a:schemeClr val="accent1"/>
+          </a:effectRef>
+          <a:fontRef idx="minor">
+            <a:schemeClr val="lt1"/>
+          </a:fontRef>
+        </p:style>
+        <p:txBody>
+          <a:bodyPr rtlCol="0" anchor="ctr"/>
+          <a:lstStyle/>
+          <a:p>
+            <a:pPr algn="ctr"/>
+          </a:p>
+        </p:txBody>
+      </p:sp>
+      <p:sp>
+        <p:nvSpPr>
+          <p:cNvPr id="67" name="TextBox 66"/>
+          <p:cNvSpPr txBox="1"/>
+          <p:nvPr/>
+        </p:nvSpPr>
+        <p:spPr>
+          <a:xfrm>
+            <a:off x="8202167" y="5029200"/>
+            <a:ext cx="3456432" cy="329184"/>
+          </a:xfrm>
+          <a:prstGeom prst="rect">
+            <a:avLst/>
+          </a:prstGeom>
+          <a:noFill/>
+        </p:spPr>
+        <p:txBody>
+          <a:bodyPr wrap="square" lIns="18288" rIns="18288" tIns="0" bIns="0"/>
+          <a:lstStyle/>
+          <a:p>
+            <a:pPr algn="l">
+              <a:spcBef>
+                <a:spcPts val="0"/>
+              </a:spcBef>
+              <a:spcAft>
+                <a:spcPts val="0"/>
+              </a:spcAft>
+            </a:pPr>
+            <a:r>
+              <a:rPr sz="1600" b="1" i="0" lang="zh-CN" altLang="en-US">
+                <a:solidFill>
+                  <a:srgbClr val="6E1422"/>
+                </a:solidFill>
+                <a:latin typeface="微软雅黑"/>
+                <a:ea typeface="微软雅黑"/>
+                <a:cs typeface="微软雅黑"/>
+              </a:rPr>
+              <a:t>如果当选</a:t>
+            </a:r>
+          </a:p>
+        </p:txBody>
+      </p:sp>
+      <p:sp>
+        <p:nvSpPr>
+          <p:cNvPr id="68" name="TextBox 67"/>
+          <p:cNvSpPr txBox="1"/>
+          <p:nvPr/>
+        </p:nvSpPr>
+        <p:spPr>
+          <a:xfrm>
+            <a:off x="8220455" y="5303520"/>
+            <a:ext cx="3419856" cy="841248"/>
+          </a:xfrm>
+          <a:prstGeom prst="rect">
+            <a:avLst/>
+          </a:prstGeom>
+          <a:noFill/>
+        </p:spPr>
+        <p:txBody>
+          <a:bodyPr wrap="square" lIns="18288" rIns="18288" tIns="0" bIns="0"/>
+          <a:lstStyle/>
+          <a:p>
+            <a:pPr algn="l">
+              <a:lnSpc>
+                <a:spcPct val="108000"/>
+              </a:lnSpc>
+              <a:spcBef>
+                <a:spcPts val="0"/>
+              </a:spcBef>
+              <a:spcAft>
+                <a:spcPts val="0"/>
+              </a:spcAft>
+            </a:pPr>
+            <a:r>
+              <a:rPr sz="1500" b="0" i="0" lang="zh-CN" altLang="en-US">
+                <a:solidFill>
+                  <a:srgbClr val="2C2622"/>
+                </a:solidFill>
+                <a:latin typeface="微软雅黑"/>
+                <a:ea typeface="微软雅黑"/>
+                <a:cs typeface="微软雅黑"/>
+              </a:rPr>
+              <a:t>协助书记抓好发展党员和组织生活。</a:t>
+            </a:r>
+          </a:p>
+          <a:p>
+            <a:pPr algn="l">
+              <a:lnSpc>
+                <a:spcPct val="108000"/>
+              </a:lnSpc>
+              <a:spcBef>
+                <a:spcPts val="200"/>
+              </a:spcBef>
+              <a:spcAft>
+                <a:spcPts val="0"/>
+              </a:spcAft>
+            </a:pPr>
+            <a:r>
+              <a:rPr sz="1500" b="0" i="0" lang="zh-CN" altLang="en-US">
+                <a:solidFill>
+                  <a:srgbClr val="2C2622"/>
+                </a:solidFill>
+                <a:latin typeface="微软雅黑"/>
+                <a:ea typeface="微软雅黑"/>
+                <a:cs typeface="微软雅黑"/>
+              </a:rPr>
+              <a:t>自己先做到，再带动身边同学。</a:t>
+            </a:r>
+          </a:p>
+        </p:txBody>
+      </p:sp>
+      <p:sp>
+        <p:nvSpPr>
+          <p:cNvPr id="69" name="Rectangle 68"/>
+          <p:cNvSpPr/>
+          <p:nvPr/>
+        </p:nvSpPr>
+        <p:spPr>
+          <a:xfrm>
+            <a:off x="0" y="6473952"/>
+            <a:ext cx="12191695" cy="384048"/>
+          </a:xfrm>
+          <a:prstGeom prst="rect">
+            <a:avLst/>
+          </a:prstGeom>
+          <a:solidFill>
+            <a:srgbClr val="8E1B2C"/>
+          </a:solidFill>
+          <a:ln>
+            <a:noFill/>
+          </a:ln>
+        </p:spPr>
+        <p:style>
+          <a:lnRef idx="1">
+            <a:schemeClr val="accent1"/>
+          </a:lnRef>
+          <a:fillRef idx="3">
+            <a:schemeClr val="accent1"/>
+          </a:fillRef>
+          <a:effectRef idx="2">
+            <a:schemeClr val="accent1"/>
+          </a:effectRef>
+          <a:fontRef idx="minor">
+            <a:schemeClr val="lt1"/>
+          </a:fontRef>
+        </p:style>
+        <p:txBody>
+          <a:bodyPr rtlCol="0" anchor="ctr"/>
+          <a:lstStyle/>
+          <a:p>
+            <a:pPr algn="ctr"/>
+          </a:p>
+        </p:txBody>
+      </p:sp>
+      <p:sp>
+        <p:nvSpPr>
+          <p:cNvPr id="70" name="Rectangle 69"/>
           <p:cNvSpPr/>
           <p:nvPr/>
         </p:nvSpPr>
@@ -6718,7 +6729,7 @@
       </p:sp>
       <p:sp>
         <p:nvSpPr>
-          <p:cNvPr id="69" name="TextBox 68"/>
+          <p:cNvPr id="71" name="TextBox 70"/>
           <p:cNvSpPr txBox="1"/>
           <p:nvPr/>
         </p:nvSpPr>
@@ -6753,7 +6764,7 @@
                 <a:ea typeface="微软雅黑"/>
                 <a:cs typeface="微软雅黑"/>
               </a:rPr>
-              <a:t>恳请组织和同志们批评帮助</a:t>
+              <a:t>请同志们批评监督</a:t>
             </a:r>
           </a:p>
         </p:txBody>

</xml_diff>

<commit_message>
Refocus the election slide on party understanding and future work.
Remove the inner party-record heading, make party understanding the fourth point, and merge the closing cards into a fifth point on what to do next.

Co-authored-by: ISAAC558345 <ISAAC558345@users.noreply.github.com>
</commit_message>
<xml_diff>
--- a/入党自我介绍_一页.pptx
+++ b/入党自我介绍_一页.pptx
@@ -531,13 +531,19 @@
           <a:p/>
           <a:p>
             <a:r>
-              <a:t>我竞选党支部副书记，是希望在书记带领下，把班级组织委员的经验用到支部。如果当选，我会协助做好党员发展、教育和管理，把组织生活落到实处，及时把同学的情况向支部反映。</a:t>
+              <a:t>我竞选党支部副书记，是希望在书记带领下，把班级组织委员的经验用到支部，协助把组织建设和同学工作做实。</a:t>
             </a:r>
           </a:p>
           <a:p/>
           <a:p>
             <a:r>
-              <a:t>我的优势是熟悉推优和发展党员的程序，交办的事愿意跟到办完。不足是主动沟通还不够，理论学习还要更系统，支部工作也不能只靠班级经验。</a:t>
+              <a:t>我对党的认识是：中国共产党是中国工人阶级的先锋队，同时是中国人民和中华民族的先锋队。党的初心和使命，是为中国人民谋幸福、为中华民族谋复兴。我愿在思想上认同，在行动上靠拢，并长期接受组织的教育和考验。</a:t>
+            </a:r>
+          </a:p>
+          <a:p/>
+          <a:p>
+            <a:r>
+              <a:t>今后我会系统学习党的创新理论，主动多沟通；协助书记抓好发展党员和组织生活；自己先做到，再带动身边同学。</a:t>
             </a:r>
           </a:p>
           <a:p/>
@@ -3801,7 +3807,7 @@
                 <a:ea typeface="微软雅黑"/>
                 <a:cs typeface="微软雅黑"/>
               </a:rPr>
-              <a:t>发言顺序：基本情况　→　组织委员经历　→　为何竞选　→　如果当选</a:t>
+              <a:t>发言顺序：基本情况　→　组织委员经历　→　为何竞选　→　对党的认识　→　未来怎么做</a:t>
             </a:r>
           </a:p>
         </p:txBody>
@@ -4203,7 +4209,7 @@
         </p:nvSpPr>
         <p:spPr>
           <a:xfrm>
-            <a:off x="457200" y="2084831"/>
+            <a:off x="457200" y="2103120"/>
             <a:ext cx="457200" cy="274320"/>
           </a:xfrm>
           <a:prstGeom prst="rect">
@@ -4245,7 +4251,7 @@
         </p:nvSpPr>
         <p:spPr>
           <a:xfrm>
-            <a:off x="914400" y="2084831"/>
+            <a:off x="914400" y="2103120"/>
             <a:ext cx="1280160" cy="274320"/>
           </a:xfrm>
           <a:prstGeom prst="rect">
@@ -4287,7 +4293,7 @@
         </p:nvSpPr>
         <p:spPr>
           <a:xfrm>
-            <a:off x="914400" y="2359151"/>
+            <a:off x="914400" y="2377439"/>
             <a:ext cx="1243584" cy="9144"/>
           </a:xfrm>
           <a:prstGeom prst="rect">
@@ -4330,7 +4336,7 @@
         </p:nvSpPr>
         <p:spPr>
           <a:xfrm>
-            <a:off x="2212848" y="2084831"/>
+            <a:off x="2212848" y="2103120"/>
             <a:ext cx="457200" cy="274320"/>
           </a:xfrm>
           <a:prstGeom prst="rect">
@@ -4372,7 +4378,7 @@
         </p:nvSpPr>
         <p:spPr>
           <a:xfrm>
-            <a:off x="2670048" y="2084831"/>
+            <a:off x="2670048" y="2103120"/>
             <a:ext cx="1325880" cy="274320"/>
           </a:xfrm>
           <a:prstGeom prst="rect">
@@ -4414,7 +4420,7 @@
         </p:nvSpPr>
         <p:spPr>
           <a:xfrm>
-            <a:off x="2670048" y="2359151"/>
+            <a:off x="2670048" y="2377439"/>
             <a:ext cx="1289304" cy="9144"/>
           </a:xfrm>
           <a:prstGeom prst="rect">
@@ -4457,7 +4463,7 @@
         </p:nvSpPr>
         <p:spPr>
           <a:xfrm>
-            <a:off x="457200" y="2450592"/>
+            <a:off x="457200" y="2523744"/>
             <a:ext cx="457200" cy="274320"/>
           </a:xfrm>
           <a:prstGeom prst="rect">
@@ -4499,7 +4505,7 @@
         </p:nvSpPr>
         <p:spPr>
           <a:xfrm>
-            <a:off x="914400" y="2450592"/>
+            <a:off x="914400" y="2523744"/>
             <a:ext cx="1280160" cy="274320"/>
           </a:xfrm>
           <a:prstGeom prst="rect">
@@ -4541,7 +4547,7 @@
         </p:nvSpPr>
         <p:spPr>
           <a:xfrm>
-            <a:off x="914400" y="2724912"/>
+            <a:off x="914400" y="2798063"/>
             <a:ext cx="1243584" cy="9144"/>
           </a:xfrm>
           <a:prstGeom prst="rect">
@@ -4584,7 +4590,7 @@
         </p:nvSpPr>
         <p:spPr>
           <a:xfrm>
-            <a:off x="2212848" y="2450592"/>
+            <a:off x="2212848" y="2523744"/>
             <a:ext cx="457200" cy="274320"/>
           </a:xfrm>
           <a:prstGeom prst="rect">
@@ -4626,7 +4632,7 @@
         </p:nvSpPr>
         <p:spPr>
           <a:xfrm>
-            <a:off x="2670048" y="2450592"/>
+            <a:off x="2670048" y="2523744"/>
             <a:ext cx="1325880" cy="274320"/>
           </a:xfrm>
           <a:prstGeom prst="rect">
@@ -4668,7 +4674,7 @@
         </p:nvSpPr>
         <p:spPr>
           <a:xfrm>
-            <a:off x="2670048" y="2724912"/>
+            <a:off x="2670048" y="2798063"/>
             <a:ext cx="1289304" cy="9144"/>
           </a:xfrm>
           <a:prstGeom prst="rect">
@@ -4705,143 +4711,13 @@
       </p:sp>
       <p:sp>
         <p:nvSpPr>
-          <p:cNvPr id="29" name="Rounded Rectangle 28"/>
-          <p:cNvSpPr/>
-          <p:nvPr/>
-        </p:nvSpPr>
-        <p:spPr>
-          <a:xfrm>
-            <a:off x="438912" y="2907792"/>
-            <a:ext cx="3566160" cy="1627632"/>
-          </a:xfrm>
-          <a:prstGeom prst="roundRect">
-            <a:avLst>
-              <a:gd name="adj" fmla="val 8000"/>
-            </a:avLst>
-          </a:prstGeom>
-          <a:solidFill>
-            <a:srgbClr val="F8EFEA"/>
-          </a:solidFill>
-          <a:ln>
-            <a:noFill/>
-          </a:ln>
-        </p:spPr>
-        <p:style>
-          <a:lnRef idx="1">
-            <a:schemeClr val="accent1"/>
-          </a:lnRef>
-          <a:fillRef idx="3">
-            <a:schemeClr val="accent1"/>
-          </a:fillRef>
-          <a:effectRef idx="2">
-            <a:schemeClr val="accent1"/>
-          </a:effectRef>
-          <a:fontRef idx="minor">
-            <a:schemeClr val="lt1"/>
-          </a:fontRef>
-        </p:style>
-        <p:txBody>
-          <a:bodyPr rtlCol="0" anchor="ctr"/>
-          <a:lstStyle/>
-          <a:p>
-            <a:pPr algn="ctr"/>
-          </a:p>
-        </p:txBody>
-      </p:sp>
-      <p:sp>
-        <p:nvSpPr>
-          <p:cNvPr id="30" name="Rectangle 29"/>
-          <p:cNvSpPr/>
-          <p:nvPr/>
-        </p:nvSpPr>
-        <p:spPr>
-          <a:xfrm>
-            <a:off x="438912" y="2907792"/>
-            <a:ext cx="73152" cy="1627632"/>
-          </a:xfrm>
-          <a:prstGeom prst="rect">
-            <a:avLst/>
-          </a:prstGeom>
-          <a:solidFill>
-            <a:srgbClr val="8E1B2C"/>
-          </a:solidFill>
-          <a:ln>
-            <a:noFill/>
-          </a:ln>
-        </p:spPr>
-        <p:style>
-          <a:lnRef idx="1">
-            <a:schemeClr val="accent1"/>
-          </a:lnRef>
-          <a:fillRef idx="3">
-            <a:schemeClr val="accent1"/>
-          </a:fillRef>
-          <a:effectRef idx="2">
-            <a:schemeClr val="accent1"/>
-          </a:effectRef>
-          <a:fontRef idx="minor">
-            <a:schemeClr val="lt1"/>
-          </a:fontRef>
-        </p:style>
-        <p:txBody>
-          <a:bodyPr rtlCol="0" anchor="ctr"/>
-          <a:lstStyle/>
-          <a:p>
-            <a:pPr algn="ctr"/>
-          </a:p>
-        </p:txBody>
-      </p:sp>
-      <p:sp>
-        <p:nvSpPr>
-          <p:cNvPr id="31" name="TextBox 30"/>
+          <p:cNvPr id="29" name="TextBox 28"/>
           <p:cNvSpPr txBox="1"/>
           <p:nvPr/>
         </p:nvSpPr>
         <p:spPr>
           <a:xfrm>
-            <a:off x="640080" y="2980944"/>
-            <a:ext cx="3200400" cy="274320"/>
-          </a:xfrm>
-          <a:prstGeom prst="rect">
-            <a:avLst/>
-          </a:prstGeom>
-          <a:noFill/>
-        </p:spPr>
-        <p:txBody>
-          <a:bodyPr wrap="square" lIns="18288" rIns="18288" tIns="0" bIns="0"/>
-          <a:lstStyle/>
-          <a:p>
-            <a:pPr algn="l">
-              <a:spcBef>
-                <a:spcPts val="0"/>
-              </a:spcBef>
-              <a:spcAft>
-                <a:spcPts val="0"/>
-              </a:spcAft>
-            </a:pPr>
-            <a:r>
-              <a:rPr sz="1400" b="1" i="0" lang="zh-CN" altLang="en-US">
-                <a:solidFill>
-                  <a:srgbClr val="6E1422"/>
-                </a:solidFill>
-                <a:latin typeface="微软雅黑"/>
-                <a:ea typeface="微软雅黑"/>
-                <a:cs typeface="微软雅黑"/>
-              </a:rPr>
-              <a:t>党内经历</a:t>
-            </a:r>
-          </a:p>
-        </p:txBody>
-      </p:sp>
-      <p:sp>
-        <p:nvSpPr>
-          <p:cNvPr id="32" name="TextBox 31"/>
-          <p:cNvSpPr txBox="1"/>
-          <p:nvPr/>
-        </p:nvSpPr>
-        <p:spPr>
-          <a:xfrm>
-            <a:off x="640080" y="3291840"/>
+            <a:off x="457200" y="3035808"/>
             <a:ext cx="960120" cy="274320"/>
           </a:xfrm>
           <a:prstGeom prst="rect">
@@ -4877,14 +4753,14 @@
       </p:sp>
       <p:sp>
         <p:nvSpPr>
-          <p:cNvPr id="33" name="TextBox 32"/>
+          <p:cNvPr id="30" name="TextBox 29"/>
           <p:cNvSpPr txBox="1"/>
           <p:nvPr/>
         </p:nvSpPr>
         <p:spPr>
           <a:xfrm>
-            <a:off x="1600200" y="3291840"/>
-            <a:ext cx="2240280" cy="274320"/>
+            <a:off x="1417320" y="3035808"/>
+            <a:ext cx="2560320" cy="274320"/>
           </a:xfrm>
           <a:prstGeom prst="rect">
             <a:avLst/>
@@ -4919,14 +4795,14 @@
       </p:sp>
       <p:sp>
         <p:nvSpPr>
-          <p:cNvPr id="34" name="Rectangle 33"/>
+          <p:cNvPr id="31" name="Rectangle 30"/>
           <p:cNvSpPr/>
           <p:nvPr/>
         </p:nvSpPr>
         <p:spPr>
           <a:xfrm>
-            <a:off x="1600200" y="3566160"/>
-            <a:ext cx="2203704" cy="9144"/>
+            <a:off x="1417320" y="3310127"/>
+            <a:ext cx="2523744" cy="9144"/>
           </a:xfrm>
           <a:prstGeom prst="rect">
             <a:avLst/>
@@ -4962,13 +4838,13 @@
       </p:sp>
       <p:sp>
         <p:nvSpPr>
-          <p:cNvPr id="35" name="TextBox 34"/>
+          <p:cNvPr id="32" name="TextBox 31"/>
           <p:cNvSpPr txBox="1"/>
           <p:nvPr/>
         </p:nvSpPr>
         <p:spPr>
           <a:xfrm>
-            <a:off x="640080" y="3694176"/>
+            <a:off x="457200" y="3547872"/>
             <a:ext cx="960120" cy="274320"/>
           </a:xfrm>
           <a:prstGeom prst="rect">
@@ -5004,14 +4880,14 @@
       </p:sp>
       <p:sp>
         <p:nvSpPr>
-          <p:cNvPr id="36" name="TextBox 35"/>
+          <p:cNvPr id="33" name="TextBox 32"/>
           <p:cNvSpPr txBox="1"/>
           <p:nvPr/>
         </p:nvSpPr>
         <p:spPr>
           <a:xfrm>
-            <a:off x="1600200" y="3694176"/>
-            <a:ext cx="2240280" cy="274320"/>
+            <a:off x="1417320" y="3547872"/>
+            <a:ext cx="2560320" cy="274320"/>
           </a:xfrm>
           <a:prstGeom prst="rect">
             <a:avLst/>
@@ -5046,14 +4922,14 @@
       </p:sp>
       <p:sp>
         <p:nvSpPr>
-          <p:cNvPr id="37" name="Rectangle 36"/>
+          <p:cNvPr id="34" name="Rectangle 33"/>
           <p:cNvSpPr/>
           <p:nvPr/>
         </p:nvSpPr>
         <p:spPr>
           <a:xfrm>
-            <a:off x="1600200" y="3968496"/>
-            <a:ext cx="2203704" cy="9144"/>
+            <a:off x="1417320" y="3822191"/>
+            <a:ext cx="2523744" cy="9144"/>
           </a:xfrm>
           <a:prstGeom prst="rect">
             <a:avLst/>
@@ -5089,13 +4965,13 @@
       </p:sp>
       <p:sp>
         <p:nvSpPr>
-          <p:cNvPr id="38" name="TextBox 37"/>
+          <p:cNvPr id="35" name="TextBox 34"/>
           <p:cNvSpPr txBox="1"/>
           <p:nvPr/>
         </p:nvSpPr>
         <p:spPr>
           <a:xfrm>
-            <a:off x="640080" y="4096512"/>
+            <a:off x="457200" y="4059936"/>
             <a:ext cx="960120" cy="274320"/>
           </a:xfrm>
           <a:prstGeom prst="rect">
@@ -5131,14 +5007,14 @@
       </p:sp>
       <p:sp>
         <p:nvSpPr>
-          <p:cNvPr id="39" name="TextBox 38"/>
+          <p:cNvPr id="36" name="TextBox 35"/>
           <p:cNvSpPr txBox="1"/>
           <p:nvPr/>
         </p:nvSpPr>
         <p:spPr>
           <a:xfrm>
-            <a:off x="1600200" y="4096512"/>
-            <a:ext cx="2240280" cy="274320"/>
+            <a:off x="1417320" y="4059936"/>
+            <a:ext cx="2560320" cy="274320"/>
           </a:xfrm>
           <a:prstGeom prst="rect">
             <a:avLst/>
@@ -5173,14 +5049,14 @@
       </p:sp>
       <p:sp>
         <p:nvSpPr>
-          <p:cNvPr id="40" name="Rectangle 39"/>
+          <p:cNvPr id="37" name="Rectangle 36"/>
           <p:cNvSpPr/>
           <p:nvPr/>
         </p:nvSpPr>
         <p:spPr>
           <a:xfrm>
-            <a:off x="1600200" y="4370832"/>
-            <a:ext cx="2203704" cy="9144"/>
+            <a:off x="1417320" y="4334256"/>
+            <a:ext cx="2523744" cy="9144"/>
           </a:xfrm>
           <a:prstGeom prst="rect">
             <a:avLst/>
@@ -5216,7 +5092,7 @@
       </p:sp>
       <p:sp>
         <p:nvSpPr>
-          <p:cNvPr id="41" name="Rounded Rectangle 40"/>
+          <p:cNvPr id="38" name="Rounded Rectangle 37"/>
           <p:cNvSpPr/>
           <p:nvPr/>
         </p:nvSpPr>
@@ -5261,7 +5137,7 @@
       </p:sp>
       <p:sp>
         <p:nvSpPr>
-          <p:cNvPr id="42" name="Rounded Rectangle 41"/>
+          <p:cNvPr id="39" name="Rounded Rectangle 38"/>
           <p:cNvSpPr/>
           <p:nvPr/>
         </p:nvSpPr>
@@ -5306,7 +5182,7 @@
       </p:sp>
       <p:sp>
         <p:nvSpPr>
-          <p:cNvPr id="43" name="Rectangle 42"/>
+          <p:cNvPr id="40" name="Rectangle 39"/>
           <p:cNvSpPr/>
           <p:nvPr/>
         </p:nvSpPr>
@@ -5349,7 +5225,7 @@
       </p:sp>
       <p:sp>
         <p:nvSpPr>
-          <p:cNvPr id="44" name="TextBox 43"/>
+          <p:cNvPr id="41" name="TextBox 40"/>
           <p:cNvSpPr txBox="1"/>
           <p:nvPr/>
         </p:nvSpPr>
@@ -5391,7 +5267,7 @@
       </p:sp>
       <p:sp>
         <p:nvSpPr>
-          <p:cNvPr id="45" name="TextBox 44"/>
+          <p:cNvPr id="42" name="TextBox 41"/>
           <p:cNvSpPr txBox="1"/>
           <p:nvPr/>
         </p:nvSpPr>
@@ -5484,7 +5360,7 @@
       </p:sp>
       <p:sp>
         <p:nvSpPr>
-          <p:cNvPr id="46" name="Rounded Rectangle 45"/>
+          <p:cNvPr id="43" name="Rounded Rectangle 42"/>
           <p:cNvSpPr/>
           <p:nvPr/>
         </p:nvSpPr>
@@ -5529,7 +5405,7 @@
       </p:sp>
       <p:sp>
         <p:nvSpPr>
-          <p:cNvPr id="47" name="Rounded Rectangle 46"/>
+          <p:cNvPr id="44" name="Rounded Rectangle 43"/>
           <p:cNvSpPr/>
           <p:nvPr/>
         </p:nvSpPr>
@@ -5574,7 +5450,7 @@
       </p:sp>
       <p:sp>
         <p:nvSpPr>
-          <p:cNvPr id="48" name="Rectangle 47"/>
+          <p:cNvPr id="45" name="Rectangle 44"/>
           <p:cNvSpPr/>
           <p:nvPr/>
         </p:nvSpPr>
@@ -5617,7 +5493,7 @@
       </p:sp>
       <p:sp>
         <p:nvSpPr>
-          <p:cNvPr id="49" name="TextBox 48"/>
+          <p:cNvPr id="46" name="TextBox 45"/>
           <p:cNvSpPr txBox="1"/>
           <p:nvPr/>
         </p:nvSpPr>
@@ -5659,7 +5535,7 @@
       </p:sp>
       <p:sp>
         <p:nvSpPr>
-          <p:cNvPr id="50" name="TextBox 49"/>
+          <p:cNvPr id="47" name="TextBox 46"/>
           <p:cNvSpPr txBox="1"/>
           <p:nvPr/>
         </p:nvSpPr>
@@ -5721,37 +5597,254 @@
                 <a:ea typeface="微软雅黑"/>
                 <a:cs typeface="微软雅黑"/>
               </a:rPr>
-              <a:t>把班级组织委员的经验用到支部。</a:t>
-            </a:r>
-          </a:p>
+              <a:t>把班级组织委员的经验用到支部，协助把组织建设和同学工作做实。</a:t>
+            </a:r>
+          </a:p>
+        </p:txBody>
+      </p:sp>
+      <p:sp>
+        <p:nvSpPr>
+          <p:cNvPr id="48" name="Rounded Rectangle 47"/>
+          <p:cNvSpPr/>
+          <p:nvPr/>
+        </p:nvSpPr>
+        <p:spPr>
+          <a:xfrm>
+            <a:off x="320040" y="4860036"/>
+            <a:ext cx="6583680" cy="1444752"/>
+          </a:xfrm>
+          <a:prstGeom prst="roundRect">
+            <a:avLst>
+              <a:gd name="adj" fmla="val 5000"/>
+            </a:avLst>
+          </a:prstGeom>
+          <a:solidFill>
+            <a:srgbClr val="E3D9CE"/>
+          </a:solidFill>
+          <a:ln>
+            <a:noFill/>
+          </a:ln>
+        </p:spPr>
+        <p:style>
+          <a:lnRef idx="1">
+            <a:schemeClr val="accent1"/>
+          </a:lnRef>
+          <a:fillRef idx="3">
+            <a:schemeClr val="accent1"/>
+          </a:fillRef>
+          <a:effectRef idx="2">
+            <a:schemeClr val="accent1"/>
+          </a:effectRef>
+          <a:fontRef idx="minor">
+            <a:schemeClr val="lt1"/>
+          </a:fontRef>
+        </p:style>
+        <p:txBody>
+          <a:bodyPr rtlCol="0" anchor="ctr"/>
+          <a:lstStyle/>
+          <a:p>
+            <a:pPr algn="ctr"/>
+          </a:p>
+        </p:txBody>
+      </p:sp>
+      <p:sp>
+        <p:nvSpPr>
+          <p:cNvPr id="49" name="Rounded Rectangle 48"/>
+          <p:cNvSpPr/>
+          <p:nvPr/>
+        </p:nvSpPr>
+        <p:spPr>
+          <a:xfrm>
+            <a:off x="292608" y="4828032"/>
+            <a:ext cx="6583680" cy="1444752"/>
+          </a:xfrm>
+          <a:prstGeom prst="roundRect">
+            <a:avLst>
+              <a:gd name="adj" fmla="val 5000"/>
+            </a:avLst>
+          </a:prstGeom>
+          <a:solidFill>
+            <a:srgbClr val="FFFCF8"/>
+          </a:solidFill>
+          <a:ln>
+            <a:noFill/>
+          </a:ln>
+        </p:spPr>
+        <p:style>
+          <a:lnRef idx="1">
+            <a:schemeClr val="accent1"/>
+          </a:lnRef>
+          <a:fillRef idx="3">
+            <a:schemeClr val="accent1"/>
+          </a:fillRef>
+          <a:effectRef idx="2">
+            <a:schemeClr val="accent1"/>
+          </a:effectRef>
+          <a:fontRef idx="minor">
+            <a:schemeClr val="lt1"/>
+          </a:fontRef>
+        </p:style>
+        <p:txBody>
+          <a:bodyPr rtlCol="0" anchor="ctr"/>
+          <a:lstStyle/>
+          <a:p>
+            <a:pPr algn="ctr"/>
+          </a:p>
+        </p:txBody>
+      </p:sp>
+      <p:sp>
+        <p:nvSpPr>
+          <p:cNvPr id="50" name="Rounded Rectangle 49"/>
+          <p:cNvSpPr/>
+          <p:nvPr/>
+        </p:nvSpPr>
+        <p:spPr>
+          <a:xfrm>
+            <a:off x="292608" y="4828032"/>
+            <a:ext cx="6583680" cy="73152"/>
+          </a:xfrm>
+          <a:prstGeom prst="roundRect">
+            <a:avLst>
+              <a:gd name="adj" fmla="val 40000"/>
+            </a:avLst>
+          </a:prstGeom>
+          <a:solidFill>
+            <a:srgbClr val="8E1B2C"/>
+          </a:solidFill>
+          <a:ln>
+            <a:noFill/>
+          </a:ln>
+        </p:spPr>
+        <p:style>
+          <a:lnRef idx="1">
+            <a:schemeClr val="accent1"/>
+          </a:lnRef>
+          <a:fillRef idx="3">
+            <a:schemeClr val="accent1"/>
+          </a:fillRef>
+          <a:effectRef idx="2">
+            <a:schemeClr val="accent1"/>
+          </a:effectRef>
+          <a:fontRef idx="minor">
+            <a:schemeClr val="lt1"/>
+          </a:fontRef>
+        </p:style>
+        <p:txBody>
+          <a:bodyPr rtlCol="0" anchor="ctr"/>
+          <a:lstStyle/>
+          <a:p>
+            <a:pPr algn="ctr"/>
+          </a:p>
+        </p:txBody>
+      </p:sp>
+      <p:sp>
+        <p:nvSpPr>
+          <p:cNvPr id="51" name="Rectangle 50"/>
+          <p:cNvSpPr/>
+          <p:nvPr/>
+        </p:nvSpPr>
+        <p:spPr>
+          <a:xfrm>
+            <a:off x="292608" y="4873752"/>
+            <a:ext cx="6583680" cy="54864"/>
+          </a:xfrm>
+          <a:prstGeom prst="rect">
+            <a:avLst/>
+          </a:prstGeom>
+          <a:solidFill>
+            <a:srgbClr val="8E1B2C"/>
+          </a:solidFill>
+          <a:ln>
+            <a:noFill/>
+          </a:ln>
+        </p:spPr>
+        <p:style>
+          <a:lnRef idx="1">
+            <a:schemeClr val="accent1"/>
+          </a:lnRef>
+          <a:fillRef idx="3">
+            <a:schemeClr val="accent1"/>
+          </a:fillRef>
+          <a:effectRef idx="2">
+            <a:schemeClr val="accent1"/>
+          </a:effectRef>
+          <a:fontRef idx="minor">
+            <a:schemeClr val="lt1"/>
+          </a:fontRef>
+        </p:style>
+        <p:txBody>
+          <a:bodyPr rtlCol="0" anchor="ctr"/>
+          <a:lstStyle/>
+          <a:p>
+            <a:pPr algn="ctr"/>
+          </a:p>
+        </p:txBody>
+      </p:sp>
+      <p:sp>
+        <p:nvSpPr>
+          <p:cNvPr id="52" name="TextBox 51"/>
+          <p:cNvSpPr txBox="1"/>
+          <p:nvPr/>
+        </p:nvSpPr>
+        <p:spPr>
+          <a:xfrm>
+            <a:off x="438912" y="4992624"/>
+            <a:ext cx="6291072" cy="310896"/>
+          </a:xfrm>
+          <a:prstGeom prst="rect">
+            <a:avLst/>
+          </a:prstGeom>
+          <a:noFill/>
+        </p:spPr>
+        <p:txBody>
+          <a:bodyPr wrap="square" lIns="18288" rIns="18288" tIns="0" bIns="0"/>
+          <a:lstStyle/>
           <a:p>
             <a:pPr algn="l">
-              <a:lnSpc>
-                <a:spcPct val="108000"/>
-              </a:lnSpc>
               <a:spcBef>
-                <a:spcPts val="200"/>
+                <a:spcPts val="0"/>
               </a:spcBef>
               <a:spcAft>
                 <a:spcPts val="0"/>
               </a:spcAft>
             </a:pPr>
             <a:r>
-              <a:rPr sz="1500" b="0" i="0" lang="zh-CN" altLang="en-US">
+              <a:rPr sz="1600" b="1" i="0" lang="zh-CN" altLang="en-US">
                 <a:solidFill>
-                  <a:srgbClr val="2C2622"/>
+                  <a:srgbClr val="6E1422"/>
                 </a:solidFill>
                 <a:latin typeface="微软雅黑"/>
                 <a:ea typeface="微软雅黑"/>
                 <a:cs typeface="微软雅黑"/>
               </a:rPr>
-              <a:t>如果当选，我会协助做好党员发展、教育和管理，把组织生活落到实处，</a:t>
-            </a:r>
-          </a:p>
+              <a:t>四、对党的认识</a:t>
+            </a:r>
+          </a:p>
+        </p:txBody>
+      </p:sp>
+      <p:sp>
+        <p:nvSpPr>
+          <p:cNvPr id="53" name="TextBox 52"/>
+          <p:cNvSpPr txBox="1"/>
+          <p:nvPr/>
+        </p:nvSpPr>
+        <p:spPr>
+          <a:xfrm>
+            <a:off x="457200" y="5303520"/>
+            <a:ext cx="6254496" cy="877824"/>
+          </a:xfrm>
+          <a:prstGeom prst="rect">
+            <a:avLst/>
+          </a:prstGeom>
+          <a:noFill/>
+        </p:spPr>
+        <p:txBody>
+          <a:bodyPr wrap="square" lIns="18288" rIns="18288" tIns="0" bIns="0"/>
+          <a:lstStyle/>
           <a:p>
             <a:pPr algn="l">
               <a:lnSpc>
-                <a:spcPct val="108000"/>
+                <a:spcPct val="105000"/>
               </a:lnSpc>
               <a:spcBef>
                 <a:spcPts val="0"/>
@@ -5761,7 +5854,7 @@
               </a:spcAft>
             </a:pPr>
             <a:r>
-              <a:rPr sz="1500" b="0" i="0" lang="zh-CN" altLang="en-US">
+              <a:rPr sz="1400" b="0" i="0" lang="zh-CN" altLang="en-US">
                 <a:solidFill>
                   <a:srgbClr val="2C2622"/>
                 </a:solidFill>
@@ -5769,21 +5862,69 @@
                 <a:ea typeface="微软雅黑"/>
                 <a:cs typeface="微软雅黑"/>
               </a:rPr>
-              <a:t>及时把同学的情况向支部反映。</a:t>
-            </a:r>
-          </a:p>
-        </p:txBody>
-      </p:sp>
-      <p:sp>
-        <p:nvSpPr>
-          <p:cNvPr id="51" name="Rounded Rectangle 50"/>
+              <a:t>中国共产党是中国工人阶级的先锋队，同时是中国人民和中华民族的先锋队。</a:t>
+            </a:r>
+          </a:p>
+          <a:p>
+            <a:pPr algn="l">
+              <a:lnSpc>
+                <a:spcPct val="105000"/>
+              </a:lnSpc>
+              <a:spcBef>
+                <a:spcPts val="100"/>
+              </a:spcBef>
+              <a:spcAft>
+                <a:spcPts val="0"/>
+              </a:spcAft>
+            </a:pPr>
+            <a:r>
+              <a:rPr sz="1400" b="0" i="0" lang="zh-CN" altLang="en-US">
+                <a:solidFill>
+                  <a:srgbClr val="2C2622"/>
+                </a:solidFill>
+                <a:latin typeface="微软雅黑"/>
+                <a:ea typeface="微软雅黑"/>
+                <a:cs typeface="微软雅黑"/>
+              </a:rPr>
+              <a:t>党的初心和使命，是为中国人民谋幸福、为中华民族谋复兴。</a:t>
+            </a:r>
+          </a:p>
+          <a:p>
+            <a:pPr algn="l">
+              <a:lnSpc>
+                <a:spcPct val="105000"/>
+              </a:lnSpc>
+              <a:spcBef>
+                <a:spcPts val="100"/>
+              </a:spcBef>
+              <a:spcAft>
+                <a:spcPts val="0"/>
+              </a:spcAft>
+            </a:pPr>
+            <a:r>
+              <a:rPr sz="1400" b="0" i="0" lang="zh-CN" altLang="en-US">
+                <a:solidFill>
+                  <a:srgbClr val="2C2622"/>
+                </a:solidFill>
+                <a:latin typeface="微软雅黑"/>
+                <a:ea typeface="微软雅黑"/>
+                <a:cs typeface="微软雅黑"/>
+              </a:rPr>
+              <a:t>我愿在思想上认同，在行动上靠拢，并长期接受组织的教育和考验。</a:t>
+            </a:r>
+          </a:p>
+        </p:txBody>
+      </p:sp>
+      <p:sp>
+        <p:nvSpPr>
+          <p:cNvPr id="54" name="Rounded Rectangle 53"/>
           <p:cNvSpPr/>
           <p:nvPr/>
         </p:nvSpPr>
         <p:spPr>
           <a:xfrm>
-            <a:off x="320040" y="4860036"/>
-            <a:ext cx="3749039" cy="1444752"/>
+            <a:off x="7050024" y="4860036"/>
+            <a:ext cx="4873752" cy="1444752"/>
           </a:xfrm>
           <a:prstGeom prst="roundRect">
             <a:avLst>
@@ -5821,14 +5962,14 @@
       </p:sp>
       <p:sp>
         <p:nvSpPr>
-          <p:cNvPr id="52" name="Rounded Rectangle 51"/>
+          <p:cNvPr id="55" name="Rounded Rectangle 54"/>
           <p:cNvSpPr/>
           <p:nvPr/>
         </p:nvSpPr>
         <p:spPr>
           <a:xfrm>
-            <a:off x="292608" y="4828032"/>
-            <a:ext cx="3749039" cy="1444752"/>
+            <a:off x="7022592" y="4828032"/>
+            <a:ext cx="4873752" cy="1444752"/>
           </a:xfrm>
           <a:prstGeom prst="roundRect">
             <a:avLst>
@@ -5866,14 +6007,14 @@
       </p:sp>
       <p:sp>
         <p:nvSpPr>
-          <p:cNvPr id="53" name="Rounded Rectangle 52"/>
+          <p:cNvPr id="56" name="Rounded Rectangle 55"/>
           <p:cNvSpPr/>
           <p:nvPr/>
         </p:nvSpPr>
         <p:spPr>
           <a:xfrm>
-            <a:off x="292608" y="4828032"/>
-            <a:ext cx="3749039" cy="73152"/>
+            <a:off x="7022592" y="4828032"/>
+            <a:ext cx="4873752" cy="73152"/>
           </a:xfrm>
           <a:prstGeom prst="roundRect">
             <a:avLst>
@@ -5911,14 +6052,14 @@
       </p:sp>
       <p:sp>
         <p:nvSpPr>
-          <p:cNvPr id="54" name="Rectangle 53"/>
+          <p:cNvPr id="57" name="Rectangle 56"/>
           <p:cNvSpPr/>
           <p:nvPr/>
         </p:nvSpPr>
         <p:spPr>
           <a:xfrm>
-            <a:off x="292608" y="4873752"/>
-            <a:ext cx="3749039" cy="54864"/>
+            <a:off x="7022592" y="4873752"/>
+            <a:ext cx="4873752" cy="54864"/>
           </a:xfrm>
           <a:prstGeom prst="rect">
             <a:avLst/>
@@ -5954,14 +6095,14 @@
       </p:sp>
       <p:sp>
         <p:nvSpPr>
-          <p:cNvPr id="55" name="TextBox 54"/>
+          <p:cNvPr id="58" name="TextBox 57"/>
           <p:cNvSpPr txBox="1"/>
           <p:nvPr/>
         </p:nvSpPr>
         <p:spPr>
           <a:xfrm>
-            <a:off x="438912" y="5029200"/>
-            <a:ext cx="3456432" cy="329184"/>
+            <a:off x="7168896" y="4992624"/>
+            <a:ext cx="4581144" cy="310896"/>
           </a:xfrm>
           <a:prstGeom prst="rect">
             <a:avLst/>
@@ -5989,21 +6130,21 @@
                 <a:ea typeface="微软雅黑"/>
                 <a:cs typeface="微软雅黑"/>
               </a:rPr>
-              <a:t>四、组织委员给我的</a:t>
-            </a:r>
-          </a:p>
-        </p:txBody>
-      </p:sp>
-      <p:sp>
-        <p:nvSpPr>
-          <p:cNvPr id="56" name="TextBox 55"/>
+              <a:t>五、未来该怎么去做</a:t>
+            </a:r>
+          </a:p>
+        </p:txBody>
+      </p:sp>
+      <p:sp>
+        <p:nvSpPr>
+          <p:cNvPr id="59" name="TextBox 58"/>
           <p:cNvSpPr txBox="1"/>
           <p:nvPr/>
         </p:nvSpPr>
         <p:spPr>
           <a:xfrm>
-            <a:off x="457200" y="5303520"/>
-            <a:ext cx="3419856" cy="841248"/>
+            <a:off x="7187183" y="5303520"/>
+            <a:ext cx="4544568" cy="877824"/>
           </a:xfrm>
           <a:prstGeom prst="rect">
             <a:avLst/>
@@ -6016,7 +6157,7 @@
           <a:p>
             <a:pPr algn="l">
               <a:lnSpc>
-                <a:spcPct val="108000"/>
+                <a:spcPct val="105000"/>
               </a:lnSpc>
               <a:spcBef>
                 <a:spcPts val="0"/>
@@ -6026,7 +6167,7 @@
               </a:spcAft>
             </a:pPr>
             <a:r>
-              <a:rPr sz="1500" b="0" i="0" lang="zh-CN" altLang="en-US">
+              <a:rPr sz="1400" b="0" i="0" lang="zh-CN" altLang="en-US">
                 <a:solidFill>
                   <a:srgbClr val="2C2622"/>
                 </a:solidFill>
@@ -6034,577 +6175,23 @@
                 <a:ea typeface="微软雅黑"/>
                 <a:cs typeface="微软雅黑"/>
               </a:rPr>
-              <a:t>熟悉推优和发展党员的程序。</a:t>
+              <a:t>系统学习党的创新理论，主动多沟通。</a:t>
             </a:r>
           </a:p>
           <a:p>
             <a:pPr algn="l">
               <a:lnSpc>
-                <a:spcPct val="108000"/>
+                <a:spcPct val="105000"/>
               </a:lnSpc>
               <a:spcBef>
-                <a:spcPts val="200"/>
+                <a:spcPts val="100"/>
               </a:spcBef>
               <a:spcAft>
                 <a:spcPts val="0"/>
               </a:spcAft>
             </a:pPr>
             <a:r>
-              <a:rPr sz="1500" b="0" i="0" lang="zh-CN" altLang="en-US">
-                <a:solidFill>
-                  <a:srgbClr val="2C2622"/>
-                </a:solidFill>
-                <a:latin typeface="微软雅黑"/>
-                <a:ea typeface="微软雅黑"/>
-                <a:cs typeface="微软雅黑"/>
-              </a:rPr>
-              <a:t>交办的事愿意跟到办完。</a:t>
-            </a:r>
-          </a:p>
-        </p:txBody>
-      </p:sp>
-      <p:sp>
-        <p:nvSpPr>
-          <p:cNvPr id="57" name="Rounded Rectangle 56"/>
-          <p:cNvSpPr/>
-          <p:nvPr/>
-        </p:nvSpPr>
-        <p:spPr>
-          <a:xfrm>
-            <a:off x="4201668" y="4860036"/>
-            <a:ext cx="3749039" cy="1444752"/>
-          </a:xfrm>
-          <a:prstGeom prst="roundRect">
-            <a:avLst>
-              <a:gd name="adj" fmla="val 5000"/>
-            </a:avLst>
-          </a:prstGeom>
-          <a:solidFill>
-            <a:srgbClr val="E3D9CE"/>
-          </a:solidFill>
-          <a:ln>
-            <a:noFill/>
-          </a:ln>
-        </p:spPr>
-        <p:style>
-          <a:lnRef idx="1">
-            <a:schemeClr val="accent1"/>
-          </a:lnRef>
-          <a:fillRef idx="3">
-            <a:schemeClr val="accent1"/>
-          </a:fillRef>
-          <a:effectRef idx="2">
-            <a:schemeClr val="accent1"/>
-          </a:effectRef>
-          <a:fontRef idx="minor">
-            <a:schemeClr val="lt1"/>
-          </a:fontRef>
-        </p:style>
-        <p:txBody>
-          <a:bodyPr rtlCol="0" anchor="ctr"/>
-          <a:lstStyle/>
-          <a:p>
-            <a:pPr algn="ctr"/>
-          </a:p>
-        </p:txBody>
-      </p:sp>
-      <p:sp>
-        <p:nvSpPr>
-          <p:cNvPr id="58" name="Rounded Rectangle 57"/>
-          <p:cNvSpPr/>
-          <p:nvPr/>
-        </p:nvSpPr>
-        <p:spPr>
-          <a:xfrm>
-            <a:off x="4174235" y="4828032"/>
-            <a:ext cx="3749039" cy="1444752"/>
-          </a:xfrm>
-          <a:prstGeom prst="roundRect">
-            <a:avLst>
-              <a:gd name="adj" fmla="val 5000"/>
-            </a:avLst>
-          </a:prstGeom>
-          <a:solidFill>
-            <a:srgbClr val="FFFCF8"/>
-          </a:solidFill>
-          <a:ln>
-            <a:noFill/>
-          </a:ln>
-        </p:spPr>
-        <p:style>
-          <a:lnRef idx="1">
-            <a:schemeClr val="accent1"/>
-          </a:lnRef>
-          <a:fillRef idx="3">
-            <a:schemeClr val="accent1"/>
-          </a:fillRef>
-          <a:effectRef idx="2">
-            <a:schemeClr val="accent1"/>
-          </a:effectRef>
-          <a:fontRef idx="minor">
-            <a:schemeClr val="lt1"/>
-          </a:fontRef>
-        </p:style>
-        <p:txBody>
-          <a:bodyPr rtlCol="0" anchor="ctr"/>
-          <a:lstStyle/>
-          <a:p>
-            <a:pPr algn="ctr"/>
-          </a:p>
-        </p:txBody>
-      </p:sp>
-      <p:sp>
-        <p:nvSpPr>
-          <p:cNvPr id="59" name="Rounded Rectangle 58"/>
-          <p:cNvSpPr/>
-          <p:nvPr/>
-        </p:nvSpPr>
-        <p:spPr>
-          <a:xfrm>
-            <a:off x="4174235" y="4828032"/>
-            <a:ext cx="3749039" cy="73152"/>
-          </a:xfrm>
-          <a:prstGeom prst="roundRect">
-            <a:avLst>
-              <a:gd name="adj" fmla="val 40000"/>
-            </a:avLst>
-          </a:prstGeom>
-          <a:solidFill>
-            <a:srgbClr val="8E1B2C"/>
-          </a:solidFill>
-          <a:ln>
-            <a:noFill/>
-          </a:ln>
-        </p:spPr>
-        <p:style>
-          <a:lnRef idx="1">
-            <a:schemeClr val="accent1"/>
-          </a:lnRef>
-          <a:fillRef idx="3">
-            <a:schemeClr val="accent1"/>
-          </a:fillRef>
-          <a:effectRef idx="2">
-            <a:schemeClr val="accent1"/>
-          </a:effectRef>
-          <a:fontRef idx="minor">
-            <a:schemeClr val="lt1"/>
-          </a:fontRef>
-        </p:style>
-        <p:txBody>
-          <a:bodyPr rtlCol="0" anchor="ctr"/>
-          <a:lstStyle/>
-          <a:p>
-            <a:pPr algn="ctr"/>
-          </a:p>
-        </p:txBody>
-      </p:sp>
-      <p:sp>
-        <p:nvSpPr>
-          <p:cNvPr id="60" name="Rectangle 59"/>
-          <p:cNvSpPr/>
-          <p:nvPr/>
-        </p:nvSpPr>
-        <p:spPr>
-          <a:xfrm>
-            <a:off x="4174235" y="4873752"/>
-            <a:ext cx="3749039" cy="54864"/>
-          </a:xfrm>
-          <a:prstGeom prst="rect">
-            <a:avLst/>
-          </a:prstGeom>
-          <a:solidFill>
-            <a:srgbClr val="8E1B2C"/>
-          </a:solidFill>
-          <a:ln>
-            <a:noFill/>
-          </a:ln>
-        </p:spPr>
-        <p:style>
-          <a:lnRef idx="1">
-            <a:schemeClr val="accent1"/>
-          </a:lnRef>
-          <a:fillRef idx="3">
-            <a:schemeClr val="accent1"/>
-          </a:fillRef>
-          <a:effectRef idx="2">
-            <a:schemeClr val="accent1"/>
-          </a:effectRef>
-          <a:fontRef idx="minor">
-            <a:schemeClr val="lt1"/>
-          </a:fontRef>
-        </p:style>
-        <p:txBody>
-          <a:bodyPr rtlCol="0" anchor="ctr"/>
-          <a:lstStyle/>
-          <a:p>
-            <a:pPr algn="ctr"/>
-          </a:p>
-        </p:txBody>
-      </p:sp>
-      <p:sp>
-        <p:nvSpPr>
-          <p:cNvPr id="61" name="TextBox 60"/>
-          <p:cNvSpPr txBox="1"/>
-          <p:nvPr/>
-        </p:nvSpPr>
-        <p:spPr>
-          <a:xfrm>
-            <a:off x="4320540" y="5029200"/>
-            <a:ext cx="3456432" cy="329184"/>
-          </a:xfrm>
-          <a:prstGeom prst="rect">
-            <a:avLst/>
-          </a:prstGeom>
-          <a:noFill/>
-        </p:spPr>
-        <p:txBody>
-          <a:bodyPr wrap="square" lIns="18288" rIns="18288" tIns="0" bIns="0"/>
-          <a:lstStyle/>
-          <a:p>
-            <a:pPr algn="l">
-              <a:spcBef>
-                <a:spcPts val="0"/>
-              </a:spcBef>
-              <a:spcAft>
-                <a:spcPts val="0"/>
-              </a:spcAft>
-            </a:pPr>
-            <a:r>
-              <a:rPr sz="1600" b="1" i="0" lang="zh-CN" altLang="en-US">
-                <a:solidFill>
-                  <a:srgbClr val="6E1422"/>
-                </a:solidFill>
-                <a:latin typeface="微软雅黑"/>
-                <a:ea typeface="微软雅黑"/>
-                <a:cs typeface="微软雅黑"/>
-              </a:rPr>
-              <a:t>还需要补的</a:t>
-            </a:r>
-          </a:p>
-        </p:txBody>
-      </p:sp>
-      <p:sp>
-        <p:nvSpPr>
-          <p:cNvPr id="62" name="TextBox 61"/>
-          <p:cNvSpPr txBox="1"/>
-          <p:nvPr/>
-        </p:nvSpPr>
-        <p:spPr>
-          <a:xfrm>
-            <a:off x="4338827" y="5303520"/>
-            <a:ext cx="3419856" cy="841248"/>
-          </a:xfrm>
-          <a:prstGeom prst="rect">
-            <a:avLst/>
-          </a:prstGeom>
-          <a:noFill/>
-        </p:spPr>
-        <p:txBody>
-          <a:bodyPr wrap="square" lIns="18288" rIns="18288" tIns="0" bIns="0"/>
-          <a:lstStyle/>
-          <a:p>
-            <a:pPr algn="l">
-              <a:lnSpc>
-                <a:spcPct val="108000"/>
-              </a:lnSpc>
-              <a:spcBef>
-                <a:spcPts val="0"/>
-              </a:spcBef>
-              <a:spcAft>
-                <a:spcPts val="0"/>
-              </a:spcAft>
-            </a:pPr>
-            <a:r>
-              <a:rPr sz="1500" b="0" i="0" lang="zh-CN" altLang="en-US">
-                <a:solidFill>
-                  <a:srgbClr val="2C2622"/>
-                </a:solidFill>
-                <a:latin typeface="微软雅黑"/>
-                <a:ea typeface="微软雅黑"/>
-                <a:cs typeface="微软雅黑"/>
-              </a:rPr>
-              <a:t>主动沟通还不够，理论学习要更系统。</a:t>
-            </a:r>
-          </a:p>
-          <a:p>
-            <a:pPr algn="l">
-              <a:lnSpc>
-                <a:spcPct val="108000"/>
-              </a:lnSpc>
-              <a:spcBef>
-                <a:spcPts val="200"/>
-              </a:spcBef>
-              <a:spcAft>
-                <a:spcPts val="0"/>
-              </a:spcAft>
-            </a:pPr>
-            <a:r>
-              <a:rPr sz="1500" b="0" i="0" lang="zh-CN" altLang="en-US">
-                <a:solidFill>
-                  <a:srgbClr val="2C2622"/>
-                </a:solidFill>
-                <a:latin typeface="微软雅黑"/>
-                <a:ea typeface="微软雅黑"/>
-                <a:cs typeface="微软雅黑"/>
-              </a:rPr>
-              <a:t>支部工作不能只靠班级经验。</a:t>
-            </a:r>
-          </a:p>
-        </p:txBody>
-      </p:sp>
-      <p:sp>
-        <p:nvSpPr>
-          <p:cNvPr id="63" name="Rounded Rectangle 62"/>
-          <p:cNvSpPr/>
-          <p:nvPr/>
-        </p:nvSpPr>
-        <p:spPr>
-          <a:xfrm>
-            <a:off x="8083295" y="4860036"/>
-            <a:ext cx="3749039" cy="1444752"/>
-          </a:xfrm>
-          <a:prstGeom prst="roundRect">
-            <a:avLst>
-              <a:gd name="adj" fmla="val 5000"/>
-            </a:avLst>
-          </a:prstGeom>
-          <a:solidFill>
-            <a:srgbClr val="E3D9CE"/>
-          </a:solidFill>
-          <a:ln>
-            <a:noFill/>
-          </a:ln>
-        </p:spPr>
-        <p:style>
-          <a:lnRef idx="1">
-            <a:schemeClr val="accent1"/>
-          </a:lnRef>
-          <a:fillRef idx="3">
-            <a:schemeClr val="accent1"/>
-          </a:fillRef>
-          <a:effectRef idx="2">
-            <a:schemeClr val="accent1"/>
-          </a:effectRef>
-          <a:fontRef idx="minor">
-            <a:schemeClr val="lt1"/>
-          </a:fontRef>
-        </p:style>
-        <p:txBody>
-          <a:bodyPr rtlCol="0" anchor="ctr"/>
-          <a:lstStyle/>
-          <a:p>
-            <a:pPr algn="ctr"/>
-          </a:p>
-        </p:txBody>
-      </p:sp>
-      <p:sp>
-        <p:nvSpPr>
-          <p:cNvPr id="64" name="Rounded Rectangle 63"/>
-          <p:cNvSpPr/>
-          <p:nvPr/>
-        </p:nvSpPr>
-        <p:spPr>
-          <a:xfrm>
-            <a:off x="8055863" y="4828032"/>
-            <a:ext cx="3749039" cy="1444752"/>
-          </a:xfrm>
-          <a:prstGeom prst="roundRect">
-            <a:avLst>
-              <a:gd name="adj" fmla="val 5000"/>
-            </a:avLst>
-          </a:prstGeom>
-          <a:solidFill>
-            <a:srgbClr val="FFFCF8"/>
-          </a:solidFill>
-          <a:ln>
-            <a:noFill/>
-          </a:ln>
-        </p:spPr>
-        <p:style>
-          <a:lnRef idx="1">
-            <a:schemeClr val="accent1"/>
-          </a:lnRef>
-          <a:fillRef idx="3">
-            <a:schemeClr val="accent1"/>
-          </a:fillRef>
-          <a:effectRef idx="2">
-            <a:schemeClr val="accent1"/>
-          </a:effectRef>
-          <a:fontRef idx="minor">
-            <a:schemeClr val="lt1"/>
-          </a:fontRef>
-        </p:style>
-        <p:txBody>
-          <a:bodyPr rtlCol="0" anchor="ctr"/>
-          <a:lstStyle/>
-          <a:p>
-            <a:pPr algn="ctr"/>
-          </a:p>
-        </p:txBody>
-      </p:sp>
-      <p:sp>
-        <p:nvSpPr>
-          <p:cNvPr id="65" name="Rounded Rectangle 64"/>
-          <p:cNvSpPr/>
-          <p:nvPr/>
-        </p:nvSpPr>
-        <p:spPr>
-          <a:xfrm>
-            <a:off x="8055863" y="4828032"/>
-            <a:ext cx="3749039" cy="73152"/>
-          </a:xfrm>
-          <a:prstGeom prst="roundRect">
-            <a:avLst>
-              <a:gd name="adj" fmla="val 40000"/>
-            </a:avLst>
-          </a:prstGeom>
-          <a:solidFill>
-            <a:srgbClr val="8E1B2C"/>
-          </a:solidFill>
-          <a:ln>
-            <a:noFill/>
-          </a:ln>
-        </p:spPr>
-        <p:style>
-          <a:lnRef idx="1">
-            <a:schemeClr val="accent1"/>
-          </a:lnRef>
-          <a:fillRef idx="3">
-            <a:schemeClr val="accent1"/>
-          </a:fillRef>
-          <a:effectRef idx="2">
-            <a:schemeClr val="accent1"/>
-          </a:effectRef>
-          <a:fontRef idx="minor">
-            <a:schemeClr val="lt1"/>
-          </a:fontRef>
-        </p:style>
-        <p:txBody>
-          <a:bodyPr rtlCol="0" anchor="ctr"/>
-          <a:lstStyle/>
-          <a:p>
-            <a:pPr algn="ctr"/>
-          </a:p>
-        </p:txBody>
-      </p:sp>
-      <p:sp>
-        <p:nvSpPr>
-          <p:cNvPr id="66" name="Rectangle 65"/>
-          <p:cNvSpPr/>
-          <p:nvPr/>
-        </p:nvSpPr>
-        <p:spPr>
-          <a:xfrm>
-            <a:off x="8055863" y="4873752"/>
-            <a:ext cx="3749039" cy="54864"/>
-          </a:xfrm>
-          <a:prstGeom prst="rect">
-            <a:avLst/>
-          </a:prstGeom>
-          <a:solidFill>
-            <a:srgbClr val="8E1B2C"/>
-          </a:solidFill>
-          <a:ln>
-            <a:noFill/>
-          </a:ln>
-        </p:spPr>
-        <p:style>
-          <a:lnRef idx="1">
-            <a:schemeClr val="accent1"/>
-          </a:lnRef>
-          <a:fillRef idx="3">
-            <a:schemeClr val="accent1"/>
-          </a:fillRef>
-          <a:effectRef idx="2">
-            <a:schemeClr val="accent1"/>
-          </a:effectRef>
-          <a:fontRef idx="minor">
-            <a:schemeClr val="lt1"/>
-          </a:fontRef>
-        </p:style>
-        <p:txBody>
-          <a:bodyPr rtlCol="0" anchor="ctr"/>
-          <a:lstStyle/>
-          <a:p>
-            <a:pPr algn="ctr"/>
-          </a:p>
-        </p:txBody>
-      </p:sp>
-      <p:sp>
-        <p:nvSpPr>
-          <p:cNvPr id="67" name="TextBox 66"/>
-          <p:cNvSpPr txBox="1"/>
-          <p:nvPr/>
-        </p:nvSpPr>
-        <p:spPr>
-          <a:xfrm>
-            <a:off x="8202167" y="5029200"/>
-            <a:ext cx="3456432" cy="329184"/>
-          </a:xfrm>
-          <a:prstGeom prst="rect">
-            <a:avLst/>
-          </a:prstGeom>
-          <a:noFill/>
-        </p:spPr>
-        <p:txBody>
-          <a:bodyPr wrap="square" lIns="18288" rIns="18288" tIns="0" bIns="0"/>
-          <a:lstStyle/>
-          <a:p>
-            <a:pPr algn="l">
-              <a:spcBef>
-                <a:spcPts val="0"/>
-              </a:spcBef>
-              <a:spcAft>
-                <a:spcPts val="0"/>
-              </a:spcAft>
-            </a:pPr>
-            <a:r>
-              <a:rPr sz="1600" b="1" i="0" lang="zh-CN" altLang="en-US">
-                <a:solidFill>
-                  <a:srgbClr val="6E1422"/>
-                </a:solidFill>
-                <a:latin typeface="微软雅黑"/>
-                <a:ea typeface="微软雅黑"/>
-                <a:cs typeface="微软雅黑"/>
-              </a:rPr>
-              <a:t>如果当选</a:t>
-            </a:r>
-          </a:p>
-        </p:txBody>
-      </p:sp>
-      <p:sp>
-        <p:nvSpPr>
-          <p:cNvPr id="68" name="TextBox 67"/>
-          <p:cNvSpPr txBox="1"/>
-          <p:nvPr/>
-        </p:nvSpPr>
-        <p:spPr>
-          <a:xfrm>
-            <a:off x="8220455" y="5303520"/>
-            <a:ext cx="3419856" cy="841248"/>
-          </a:xfrm>
-          <a:prstGeom prst="rect">
-            <a:avLst/>
-          </a:prstGeom>
-          <a:noFill/>
-        </p:spPr>
-        <p:txBody>
-          <a:bodyPr wrap="square" lIns="18288" rIns="18288" tIns="0" bIns="0"/>
-          <a:lstStyle/>
-          <a:p>
-            <a:pPr algn="l">
-              <a:lnSpc>
-                <a:spcPct val="108000"/>
-              </a:lnSpc>
-              <a:spcBef>
-                <a:spcPts val="0"/>
-              </a:spcBef>
-              <a:spcAft>
-                <a:spcPts val="0"/>
-              </a:spcAft>
-            </a:pPr>
-            <a:r>
-              <a:rPr sz="1500" b="0" i="0" lang="zh-CN" altLang="en-US">
+              <a:rPr sz="1400" b="0" i="0" lang="zh-CN" altLang="en-US">
                 <a:solidFill>
                   <a:srgbClr val="2C2622"/>
                 </a:solidFill>
@@ -6618,17 +6205,17 @@
           <a:p>
             <a:pPr algn="l">
               <a:lnSpc>
-                <a:spcPct val="108000"/>
+                <a:spcPct val="105000"/>
               </a:lnSpc>
               <a:spcBef>
-                <a:spcPts val="200"/>
+                <a:spcPts val="100"/>
               </a:spcBef>
               <a:spcAft>
                 <a:spcPts val="0"/>
               </a:spcAft>
             </a:pPr>
             <a:r>
-              <a:rPr sz="1500" b="0" i="0" lang="zh-CN" altLang="en-US">
+              <a:rPr sz="1400" b="0" i="0" lang="zh-CN" altLang="en-US">
                 <a:solidFill>
                   <a:srgbClr val="2C2622"/>
                 </a:solidFill>
@@ -6643,7 +6230,7 @@
       </p:sp>
       <p:sp>
         <p:nvSpPr>
-          <p:cNvPr id="69" name="Rectangle 68"/>
+          <p:cNvPr id="60" name="Rectangle 59"/>
           <p:cNvSpPr/>
           <p:nvPr/>
         </p:nvSpPr>
@@ -6686,7 +6273,7 @@
       </p:sp>
       <p:sp>
         <p:nvSpPr>
-          <p:cNvPr id="70" name="Rectangle 69"/>
+          <p:cNvPr id="61" name="Rectangle 60"/>
           <p:cNvSpPr/>
           <p:nvPr/>
         </p:nvSpPr>
@@ -6729,7 +6316,7 @@
       </p:sp>
       <p:sp>
         <p:nvSpPr>
-          <p:cNvPr id="71" name="TextBox 70"/>
+          <p:cNvPr id="62" name="TextBox 61"/>
           <p:cNvSpPr txBox="1"/>
           <p:nvPr/>
         </p:nvSpPr>

</xml_diff>